<commit_message>
Remove page-count note from professor presentation
</commit_message>
<xml_diff>
--- a/presentations/PERSONA_Professor_Revision_Update.pptx
+++ b/presentations/PERSONA_Professor_Revision_Update.pptx
@@ -2,21 +2,21 @@
 <file path=ppt/presentation.xml><?xml version="1.0" encoding="utf-8"?>
 <p:presentation xmlns:p="http://schemas.openxmlformats.org/presentationml/2006/main">
   <p:sldMasterIdLst>
-    <p:sldMasterId xmlns:r="http://schemas.openxmlformats.org/officeDocument/2006/relationships" id="2147483648" r:id="R70642cec8c1c422a"/>
+    <p:sldMasterId xmlns:r="http://schemas.openxmlformats.org/officeDocument/2006/relationships" id="2147483648" r:id="Rb58668e880f74853"/>
   </p:sldMasterIdLst>
   <p:notesMasterIdLst>
-    <p:notesMasterId xmlns:r="http://schemas.openxmlformats.org/officeDocument/2006/relationships" r:id="Rce3d5ee78bc84b3b"/>
+    <p:notesMasterId xmlns:r="http://schemas.openxmlformats.org/officeDocument/2006/relationships" r:id="Rcb909959d1c44029"/>
   </p:notesMasterIdLst>
   <p:sldIdLst>
-    <p:sldId xmlns:r="http://schemas.openxmlformats.org/officeDocument/2006/relationships" id="256" r:id="R4d2c408668a14ee9"/>
-    <p:sldId xmlns:r="http://schemas.openxmlformats.org/officeDocument/2006/relationships" id="257" r:id="Re69530a2556b4616"/>
-    <p:sldId xmlns:r="http://schemas.openxmlformats.org/officeDocument/2006/relationships" id="258" r:id="R67623541197343c1"/>
-    <p:sldId xmlns:r="http://schemas.openxmlformats.org/officeDocument/2006/relationships" id="259" r:id="R4c67cc11ca9e45db"/>
-    <p:sldId xmlns:r="http://schemas.openxmlformats.org/officeDocument/2006/relationships" id="260" r:id="R46837d95797f4b57"/>
-    <p:sldId xmlns:r="http://schemas.openxmlformats.org/officeDocument/2006/relationships" id="261" r:id="Rb26757b4b70146c5"/>
-    <p:sldId xmlns:r="http://schemas.openxmlformats.org/officeDocument/2006/relationships" id="262" r:id="R91c82173b9544d07"/>
-    <p:sldId xmlns:r="http://schemas.openxmlformats.org/officeDocument/2006/relationships" id="263" r:id="R2a06bdb4cd374f11"/>
-    <p:sldId xmlns:r="http://schemas.openxmlformats.org/officeDocument/2006/relationships" id="264" r:id="R61e9e0c271274066"/>
+    <p:sldId xmlns:r="http://schemas.openxmlformats.org/officeDocument/2006/relationships" id="256" r:id="R6747bdfdd57146f8"/>
+    <p:sldId xmlns:r="http://schemas.openxmlformats.org/officeDocument/2006/relationships" id="257" r:id="Rd7272bcf57f049e3"/>
+    <p:sldId xmlns:r="http://schemas.openxmlformats.org/officeDocument/2006/relationships" id="258" r:id="R5492538a1d224056"/>
+    <p:sldId xmlns:r="http://schemas.openxmlformats.org/officeDocument/2006/relationships" id="259" r:id="R654432e699254de3"/>
+    <p:sldId xmlns:r="http://schemas.openxmlformats.org/officeDocument/2006/relationships" id="260" r:id="R19bae1f7bc414577"/>
+    <p:sldId xmlns:r="http://schemas.openxmlformats.org/officeDocument/2006/relationships" id="261" r:id="R85707f26ac8a489e"/>
+    <p:sldId xmlns:r="http://schemas.openxmlformats.org/officeDocument/2006/relationships" id="262" r:id="Rac48723caeef4fad"/>
+    <p:sldId xmlns:r="http://schemas.openxmlformats.org/officeDocument/2006/relationships" id="263" r:id="Rb54a6bf42bf047a9"/>
+    <p:sldId xmlns:r="http://schemas.openxmlformats.org/officeDocument/2006/relationships" id="264" r:id="R9cdbd43c73844208"/>
   </p:sldIdLst>
   <p:sldSz cx="12192000" cy="6858000"/>
   <p:notesSz cx="6858000" cy="9144000"/>
@@ -1140,7 +1140,7 @@
           </a:p>
           <a:p xmlns:a="http://schemas.openxmlformats.org/drawingml/2006/main">
             <a:r>
-              <a:t>The page count is not itself a compliance problem; the official Papers call encourages 5,000-8,000 words excluding references, captions, and appendices.</a:t>
+              <a:t>The remaining work is limited to supplementary-material, layout, and reference checks.</a:t>
             </a:r>
           </a:p>
           <a:p xmlns:a="http://schemas.openxmlformats.org/drawingml/2006/main">
@@ -1161,11 +1161,6 @@
           <a:p xmlns:a="http://schemas.openxmlformats.org/drawingml/2006/main">
             <a:r>
               <a:t>- https://chi2027.acm.org/authors/papers/</a:t>
-            </a:r>
-          </a:p>
-          <a:p xmlns:a="http://schemas.openxmlformats.org/drawingml/2006/main">
-            <a:r>
-              <a:t>- https://chi2027.acm.org/chi-publication-formats/</a:t>
             </a:r>
           </a:p>
         </p:txBody>
@@ -1333,7 +1328,7 @@
   </p:cSld>
   <p:clrMap bg1="lt1" tx1="dk1" bg2="lt2" tx2="dk2" accent1="accent1" accent2="accent2" accent3="accent3" accent4="accent4" accent5="accent5" accent6="accent6" hlink="hlink" folHlink="folHlink"/>
   <p:sldLayoutIdLst>
-    <p:sldLayoutId xmlns:r="http://schemas.openxmlformats.org/officeDocument/2006/relationships" id="2147483649" r:id="Rb2bf690669354c21"/>
+    <p:sldLayoutId xmlns:r="http://schemas.openxmlformats.org/officeDocument/2006/relationships" id="2147483649" r:id="Rda0407e4e06c4558"/>
   </p:sldLayoutIdLst>
   <p:txStyles>
     <p:titleStyle>
@@ -2134,7 +2129,7 @@
           <p:cNvPr id="6" name="cover-eyebrow">
             <a:extLst xmlns:a="http://schemas.openxmlformats.org/drawingml/2006/main">
               <a:ext uri="{FF2B5EF4-FFF2-40B4-BE49-F238E27FC236}">
-                <a16:creationId xmlns:a16="http://schemas.microsoft.com/office/drawing/2014/main" id="{4E0EDF0B-A79D-4F90-A570-991E58521802}"/>
+                <a16:creationId xmlns:a16="http://schemas.microsoft.com/office/drawing/2014/main" id="{B7CFE7B5-E655-4D0C-8301-55CDAEB4C04D}"/>
               </a:ext>
             </a:extLst>
           </p:cNvPr>
@@ -2192,7 +2187,7 @@
           <p:cNvPr id="2" name="cover-title">
             <a:extLst xmlns:a="http://schemas.openxmlformats.org/drawingml/2006/main">
               <a:ext uri="{FF2B5EF4-FFF2-40B4-BE49-F238E27FC236}">
-                <a16:creationId xmlns:a16="http://schemas.microsoft.com/office/drawing/2014/main" id="{2BD33831-AB2E-4842-9BCA-F3D47306E52A}"/>
+                <a16:creationId xmlns:a16="http://schemas.microsoft.com/office/drawing/2014/main" id="{BD45DD16-8E12-4705-A9E5-C101F463E12B}"/>
               </a:ext>
             </a:extLst>
           </p:cNvPr>
@@ -2250,7 +2245,7 @@
           <p:cNvPr id="3" name="cover-rule">
             <a:extLst xmlns:a="http://schemas.openxmlformats.org/drawingml/2006/main">
               <a:ext uri="{FF2B5EF4-FFF2-40B4-BE49-F238E27FC236}">
-                <a16:creationId xmlns:a16="http://schemas.microsoft.com/office/drawing/2014/main" id="{BFC596C2-E74E-4894-A323-0E9FDA11F453}"/>
+                <a16:creationId xmlns:a16="http://schemas.microsoft.com/office/drawing/2014/main" id="{A4E84617-740C-4422-BBDD-62487EA32027}"/>
               </a:ext>
             </a:extLst>
           </p:cNvPr>
@@ -2283,7 +2278,7 @@
           <p:cNvPr id="4" name="cover-subtitle">
             <a:extLst xmlns:a="http://schemas.openxmlformats.org/drawingml/2006/main">
               <a:ext uri="{FF2B5EF4-FFF2-40B4-BE49-F238E27FC236}">
-                <a16:creationId xmlns:a16="http://schemas.microsoft.com/office/drawing/2014/main" id="{E6ACC5DC-159A-40F8-A911-90B858908271}"/>
+                <a16:creationId xmlns:a16="http://schemas.microsoft.com/office/drawing/2014/main" id="{B0D5D12A-C9D0-43B7-9E86-152BF912C7D9}"/>
               </a:ext>
             </a:extLst>
           </p:cNvPr>
@@ -2364,7 +2359,7 @@
           <p:cNvPr id="5" name="cover-context">
             <a:extLst xmlns:a="http://schemas.openxmlformats.org/drawingml/2006/main">
               <a:ext uri="{FF2B5EF4-FFF2-40B4-BE49-F238E27FC236}">
-                <a16:creationId xmlns:a16="http://schemas.microsoft.com/office/drawing/2014/main" id="{32064A3E-E9FE-4F08-AAD4-6E744F3F6298}"/>
+                <a16:creationId xmlns:a16="http://schemas.microsoft.com/office/drawing/2014/main" id="{D4430D85-38F7-46A5-8613-9D68B4954930}"/>
               </a:ext>
             </a:extLst>
           </p:cNvPr>
@@ -2420,7 +2415,7 @@
     </p:spTree>
     <p:extLst>
       <p:ext uri="{BB962C8B-B14F-4D97-AF65-F5344CB8AC3E}">
-        <p14:creationId xmlns:p14="http://schemas.microsoft.com/office/powerpoint/2010/main" val="629278186"/>
+        <p14:creationId xmlns:p14="http://schemas.microsoft.com/office/powerpoint/2010/main" val="1754583819"/>
       </p:ext>
     </p:extLst>
   </p:cSld>
@@ -2451,7 +2446,7 @@
           <p:cNvPr id="18" name="title-2">
             <a:extLst xmlns:a="http://schemas.openxmlformats.org/drawingml/2006/main">
               <a:ext uri="{FF2B5EF4-FFF2-40B4-BE49-F238E27FC236}">
-                <a16:creationId xmlns:a16="http://schemas.microsoft.com/office/drawing/2014/main" id="{09E6A92D-967A-4FAE-8F15-9A6B3DAC1CC8}"/>
+                <a16:creationId xmlns:a16="http://schemas.microsoft.com/office/drawing/2014/main" id="{73D3AAB6-BC8A-4DF3-97DD-970251B40DF3}"/>
               </a:ext>
             </a:extLst>
           </p:cNvPr>
@@ -2509,7 +2504,7 @@
           <p:cNvPr id="2" name="accent-2">
             <a:extLst xmlns:a="http://schemas.openxmlformats.org/drawingml/2006/main">
               <a:ext uri="{FF2B5EF4-FFF2-40B4-BE49-F238E27FC236}">
-                <a16:creationId xmlns:a16="http://schemas.microsoft.com/office/drawing/2014/main" id="{8BABCD4C-86AF-422F-BF0A-A2F600BEE2BA}"/>
+                <a16:creationId xmlns:a16="http://schemas.microsoft.com/office/drawing/2014/main" id="{22BDB210-D856-4BAD-AA86-AAFB89CFF8D7}"/>
               </a:ext>
             </a:extLst>
           </p:cNvPr>
@@ -2542,7 +2537,7 @@
           <p:cNvPr id="3" name="page-2">
             <a:extLst xmlns:a="http://schemas.openxmlformats.org/drawingml/2006/main">
               <a:ext uri="{FF2B5EF4-FFF2-40B4-BE49-F238E27FC236}">
-                <a16:creationId xmlns:a16="http://schemas.microsoft.com/office/drawing/2014/main" id="{4D597E77-9E67-4C0D-A14D-51A5B3355640}"/>
+                <a16:creationId xmlns:a16="http://schemas.microsoft.com/office/drawing/2014/main" id="{28D647B7-AC33-44CD-B2DE-BE0F53C7216C}"/>
               </a:ext>
             </a:extLst>
           </p:cNvPr>
@@ -2600,7 +2595,7 @@
           <p:cNvPr id="4" name="risk-num-0">
             <a:extLst xmlns:a="http://schemas.openxmlformats.org/drawingml/2006/main">
               <a:ext uri="{FF2B5EF4-FFF2-40B4-BE49-F238E27FC236}">
-                <a16:creationId xmlns:a16="http://schemas.microsoft.com/office/drawing/2014/main" id="{244D8E64-2C0B-4038-9880-A87BC282766A}"/>
+                <a16:creationId xmlns:a16="http://schemas.microsoft.com/office/drawing/2014/main" id="{6C34392E-DFC4-45DA-8097-A2E7074066AE}"/>
               </a:ext>
             </a:extLst>
           </p:cNvPr>
@@ -2658,7 +2653,7 @@
           <p:cNvPr id="5" name="risk-title-0">
             <a:extLst xmlns:a="http://schemas.openxmlformats.org/drawingml/2006/main">
               <a:ext uri="{FF2B5EF4-FFF2-40B4-BE49-F238E27FC236}">
-                <a16:creationId xmlns:a16="http://schemas.microsoft.com/office/drawing/2014/main" id="{9D224662-8D20-43FC-BBBE-9C55D187BA18}"/>
+                <a16:creationId xmlns:a16="http://schemas.microsoft.com/office/drawing/2014/main" id="{490AD8B3-29F8-4557-8E96-94889BB6D446}"/>
               </a:ext>
             </a:extLst>
           </p:cNvPr>
@@ -2716,7 +2711,7 @@
           <p:cNvPr id="6" name="risk-body-0">
             <a:extLst xmlns:a="http://schemas.openxmlformats.org/drawingml/2006/main">
               <a:ext uri="{FF2B5EF4-FFF2-40B4-BE49-F238E27FC236}">
-                <a16:creationId xmlns:a16="http://schemas.microsoft.com/office/drawing/2014/main" id="{DF3C15A8-3D78-43D6-B1FE-CB67A89D3FEE}"/>
+                <a16:creationId xmlns:a16="http://schemas.microsoft.com/office/drawing/2014/main" id="{60CB7188-BFAB-4D00-82FC-A91E508CF2A2}"/>
               </a:ext>
             </a:extLst>
           </p:cNvPr>
@@ -2774,7 +2769,7 @@
           <p:cNvPr id="7" name="risk-num-1">
             <a:extLst xmlns:a="http://schemas.openxmlformats.org/drawingml/2006/main">
               <a:ext uri="{FF2B5EF4-FFF2-40B4-BE49-F238E27FC236}">
-                <a16:creationId xmlns:a16="http://schemas.microsoft.com/office/drawing/2014/main" id="{8D6C0AB7-F9DE-470E-91C3-D6DB6D7C43C7}"/>
+                <a16:creationId xmlns:a16="http://schemas.microsoft.com/office/drawing/2014/main" id="{8341683F-06E4-4D50-BDA1-E715704E4CC6}"/>
               </a:ext>
             </a:extLst>
           </p:cNvPr>
@@ -2832,7 +2827,7 @@
           <p:cNvPr id="8" name="risk-title-1">
             <a:extLst xmlns:a="http://schemas.openxmlformats.org/drawingml/2006/main">
               <a:ext uri="{FF2B5EF4-FFF2-40B4-BE49-F238E27FC236}">
-                <a16:creationId xmlns:a16="http://schemas.microsoft.com/office/drawing/2014/main" id="{CBA35C49-F5A5-447F-B80E-CE3F1CC3B78A}"/>
+                <a16:creationId xmlns:a16="http://schemas.microsoft.com/office/drawing/2014/main" id="{DFDCC48C-DB50-4C23-9612-F13573A10789}"/>
               </a:ext>
             </a:extLst>
           </p:cNvPr>
@@ -2890,7 +2885,7 @@
           <p:cNvPr id="9" name="risk-body-1">
             <a:extLst xmlns:a="http://schemas.openxmlformats.org/drawingml/2006/main">
               <a:ext uri="{FF2B5EF4-FFF2-40B4-BE49-F238E27FC236}">
-                <a16:creationId xmlns:a16="http://schemas.microsoft.com/office/drawing/2014/main" id="{4D9C500E-C2C5-4A27-A425-ADBA807BDC29}"/>
+                <a16:creationId xmlns:a16="http://schemas.microsoft.com/office/drawing/2014/main" id="{5C3D7D2C-D19B-4AD9-A16C-BED9F08CFC41}"/>
               </a:ext>
             </a:extLst>
           </p:cNvPr>
@@ -2948,7 +2943,7 @@
           <p:cNvPr id="10" name="risk-num-2">
             <a:extLst xmlns:a="http://schemas.openxmlformats.org/drawingml/2006/main">
               <a:ext uri="{FF2B5EF4-FFF2-40B4-BE49-F238E27FC236}">
-                <a16:creationId xmlns:a16="http://schemas.microsoft.com/office/drawing/2014/main" id="{E52E7CDA-3BD4-43A2-943D-53E820760495}"/>
+                <a16:creationId xmlns:a16="http://schemas.microsoft.com/office/drawing/2014/main" id="{A5941659-0D99-4E88-AC19-043E1BA45C99}"/>
               </a:ext>
             </a:extLst>
           </p:cNvPr>
@@ -3006,7 +3001,7 @@
           <p:cNvPr id="11" name="risk-title-2">
             <a:extLst xmlns:a="http://schemas.openxmlformats.org/drawingml/2006/main">
               <a:ext uri="{FF2B5EF4-FFF2-40B4-BE49-F238E27FC236}">
-                <a16:creationId xmlns:a16="http://schemas.microsoft.com/office/drawing/2014/main" id="{528A1F06-0DD0-4712-AB5F-02ACF694D628}"/>
+                <a16:creationId xmlns:a16="http://schemas.microsoft.com/office/drawing/2014/main" id="{ECDC7C29-B7A3-428A-905E-478642FF3139}"/>
               </a:ext>
             </a:extLst>
           </p:cNvPr>
@@ -3064,7 +3059,7 @@
           <p:cNvPr id="12" name="risk-body-2">
             <a:extLst xmlns:a="http://schemas.openxmlformats.org/drawingml/2006/main">
               <a:ext uri="{FF2B5EF4-FFF2-40B4-BE49-F238E27FC236}">
-                <a16:creationId xmlns:a16="http://schemas.microsoft.com/office/drawing/2014/main" id="{4D6DB2C0-C38F-42C1-9D00-5E1802BEFA59}"/>
+                <a16:creationId xmlns:a16="http://schemas.microsoft.com/office/drawing/2014/main" id="{599BBE15-F8A4-4F71-9242-B74B1291F86A}"/>
               </a:ext>
             </a:extLst>
           </p:cNvPr>
@@ -3122,7 +3117,7 @@
           <p:cNvPr id="13" name="risk-num-3">
             <a:extLst xmlns:a="http://schemas.openxmlformats.org/drawingml/2006/main">
               <a:ext uri="{FF2B5EF4-FFF2-40B4-BE49-F238E27FC236}">
-                <a16:creationId xmlns:a16="http://schemas.microsoft.com/office/drawing/2014/main" id="{B594DEA5-5EB3-446E-9084-9B52FD8877F4}"/>
+                <a16:creationId xmlns:a16="http://schemas.microsoft.com/office/drawing/2014/main" id="{DADE40DF-B183-4B59-A8A7-D26F2177A8BB}"/>
               </a:ext>
             </a:extLst>
           </p:cNvPr>
@@ -3180,7 +3175,7 @@
           <p:cNvPr id="14" name="risk-title-3">
             <a:extLst xmlns:a="http://schemas.openxmlformats.org/drawingml/2006/main">
               <a:ext uri="{FF2B5EF4-FFF2-40B4-BE49-F238E27FC236}">
-                <a16:creationId xmlns:a16="http://schemas.microsoft.com/office/drawing/2014/main" id="{DBB8E047-F5F4-4688-A6AA-7B3AEC0F7A3C}"/>
+                <a16:creationId xmlns:a16="http://schemas.microsoft.com/office/drawing/2014/main" id="{1EA133BE-6CAD-49BD-A225-7DC2DF436FCB}"/>
               </a:ext>
             </a:extLst>
           </p:cNvPr>
@@ -3238,7 +3233,7 @@
           <p:cNvPr id="15" name="risk-body-3">
             <a:extLst xmlns:a="http://schemas.openxmlformats.org/drawingml/2006/main">
               <a:ext uri="{FF2B5EF4-FFF2-40B4-BE49-F238E27FC236}">
-                <a16:creationId xmlns:a16="http://schemas.microsoft.com/office/drawing/2014/main" id="{3BC271BC-F2E4-40B3-B5A5-748C0F6F4D9E}"/>
+                <a16:creationId xmlns:a16="http://schemas.microsoft.com/office/drawing/2014/main" id="{00EE12B2-3BDC-4C25-A4D3-DC1883BE4A16}"/>
               </a:ext>
             </a:extLst>
           </p:cNvPr>
@@ -3296,7 +3291,7 @@
           <p:cNvPr id="16" name="unchanged-band">
             <a:extLst xmlns:a="http://schemas.openxmlformats.org/drawingml/2006/main">
               <a:ext uri="{FF2B5EF4-FFF2-40B4-BE49-F238E27FC236}">
-                <a16:creationId xmlns:a16="http://schemas.microsoft.com/office/drawing/2014/main" id="{1BFC01DB-6968-4770-A4DF-8E773D54284A}"/>
+                <a16:creationId xmlns:a16="http://schemas.microsoft.com/office/drawing/2014/main" id="{03530CDD-7574-4386-82AB-5EECD97D5375}"/>
               </a:ext>
             </a:extLst>
           </p:cNvPr>
@@ -3329,7 +3324,7 @@
           <p:cNvPr id="17" name="unchanged-copy">
             <a:extLst xmlns:a="http://schemas.openxmlformats.org/drawingml/2006/main">
               <a:ext uri="{FF2B5EF4-FFF2-40B4-BE49-F238E27FC236}">
-                <a16:creationId xmlns:a16="http://schemas.microsoft.com/office/drawing/2014/main" id="{9534E984-38BF-4AF2-B3DA-C8B85E3B1973}"/>
+                <a16:creationId xmlns:a16="http://schemas.microsoft.com/office/drawing/2014/main" id="{DB53B535-23E7-4F82-BC13-A445D931C3A6}"/>
               </a:ext>
             </a:extLst>
           </p:cNvPr>
@@ -3385,7 +3380,7 @@
     </p:spTree>
     <p:extLst>
       <p:ext uri="{BB962C8B-B14F-4D97-AF65-F5344CB8AC3E}">
-        <p14:creationId xmlns:p14="http://schemas.microsoft.com/office/powerpoint/2010/main" val="2104779818"/>
+        <p14:creationId xmlns:p14="http://schemas.microsoft.com/office/powerpoint/2010/main" val="1618315938"/>
       </p:ext>
     </p:extLst>
   </p:cSld>
@@ -3416,7 +3411,7 @@
           <p:cNvPr id="13" name="title-3">
             <a:extLst xmlns:a="http://schemas.openxmlformats.org/drawingml/2006/main">
               <a:ext uri="{FF2B5EF4-FFF2-40B4-BE49-F238E27FC236}">
-                <a16:creationId xmlns:a16="http://schemas.microsoft.com/office/drawing/2014/main" id="{A7AC0AB6-99D7-4641-8137-CF8E9177C6C0}"/>
+                <a16:creationId xmlns:a16="http://schemas.microsoft.com/office/drawing/2014/main" id="{0F4940B2-9D06-493A-A66A-F9C11CBC65C4}"/>
               </a:ext>
             </a:extLst>
           </p:cNvPr>
@@ -3474,7 +3469,7 @@
           <p:cNvPr id="2" name="accent-3">
             <a:extLst xmlns:a="http://schemas.openxmlformats.org/drawingml/2006/main">
               <a:ext uri="{FF2B5EF4-FFF2-40B4-BE49-F238E27FC236}">
-                <a16:creationId xmlns:a16="http://schemas.microsoft.com/office/drawing/2014/main" id="{CDEF4872-A8AB-4803-8373-F158AE6F98DE}"/>
+                <a16:creationId xmlns:a16="http://schemas.microsoft.com/office/drawing/2014/main" id="{8EAC8F5F-C3C6-49FB-AE5B-A4EFA16DB5DB}"/>
               </a:ext>
             </a:extLst>
           </p:cNvPr>
@@ -3507,7 +3502,7 @@
           <p:cNvPr id="3" name="page-3">
             <a:extLst xmlns:a="http://schemas.openxmlformats.org/drawingml/2006/main">
               <a:ext uri="{FF2B5EF4-FFF2-40B4-BE49-F238E27FC236}">
-                <a16:creationId xmlns:a16="http://schemas.microsoft.com/office/drawing/2014/main" id="{D9A8F315-D54C-4DD0-9537-A7A65FAD3B9D}"/>
+                <a16:creationId xmlns:a16="http://schemas.microsoft.com/office/drawing/2014/main" id="{DC66283C-FEAD-4640-8FA2-7A065C8A8690}"/>
               </a:ext>
             </a:extLst>
           </p:cNvPr>
@@ -3565,7 +3560,7 @@
           <p:cNvPr id="4" name="before-label">
             <a:extLst xmlns:a="http://schemas.openxmlformats.org/drawingml/2006/main">
               <a:ext uri="{FF2B5EF4-FFF2-40B4-BE49-F238E27FC236}">
-                <a16:creationId xmlns:a16="http://schemas.microsoft.com/office/drawing/2014/main" id="{1583D950-5A5E-4874-A43B-2907C079037E}"/>
+                <a16:creationId xmlns:a16="http://schemas.microsoft.com/office/drawing/2014/main" id="{A2B19B5B-DD76-4CB2-B03D-09603A5850BE}"/>
               </a:ext>
             </a:extLst>
           </p:cNvPr>
@@ -3623,7 +3618,7 @@
           <p:cNvPr id="5" name="after-label">
             <a:extLst xmlns:a="http://schemas.openxmlformats.org/drawingml/2006/main">
               <a:ext uri="{FF2B5EF4-FFF2-40B4-BE49-F238E27FC236}">
-                <a16:creationId xmlns:a16="http://schemas.microsoft.com/office/drawing/2014/main" id="{EB98EDCC-33EB-4C8D-AC69-485A92D21EA9}"/>
+                <a16:creationId xmlns:a16="http://schemas.microsoft.com/office/drawing/2014/main" id="{8A96D100-E6AB-4130-A776-E4FE63EED2BD}"/>
               </a:ext>
             </a:extLst>
           </p:cNvPr>
@@ -3681,7 +3676,7 @@
           <p:cNvPr id="6" name="before-panel">
             <a:extLst xmlns:a="http://schemas.openxmlformats.org/drawingml/2006/main">
               <a:ext uri="{FF2B5EF4-FFF2-40B4-BE49-F238E27FC236}">
-                <a16:creationId xmlns:a16="http://schemas.microsoft.com/office/drawing/2014/main" id="{C4C3D909-D168-4BA7-B95A-56F664A8D18D}"/>
+                <a16:creationId xmlns:a16="http://schemas.microsoft.com/office/drawing/2014/main" id="{EE3BE606-F42E-48B0-B9EB-4D4BD6FCAA4E}"/>
               </a:ext>
             </a:extLst>
           </p:cNvPr>
@@ -3714,7 +3709,7 @@
           <p:cNvPr id="7" name="after-panel">
             <a:extLst xmlns:a="http://schemas.openxmlformats.org/drawingml/2006/main">
               <a:ext uri="{FF2B5EF4-FFF2-40B4-BE49-F238E27FC236}">
-                <a16:creationId xmlns:a16="http://schemas.microsoft.com/office/drawing/2014/main" id="{501784B2-D0CD-490C-94BA-50C12AD76512}"/>
+                <a16:creationId xmlns:a16="http://schemas.microsoft.com/office/drawing/2014/main" id="{2EAAAFC0-4064-42A3-B3A3-E2C0A59FE813}"/>
               </a:ext>
             </a:extLst>
           </p:cNvPr>
@@ -3747,7 +3742,7 @@
           <p:cNvPr id="8" name="before-quote">
             <a:extLst xmlns:a="http://schemas.openxmlformats.org/drawingml/2006/main">
               <a:ext uri="{FF2B5EF4-FFF2-40B4-BE49-F238E27FC236}">
-                <a16:creationId xmlns:a16="http://schemas.microsoft.com/office/drawing/2014/main" id="{6DAE8AED-9D0D-4D05-8B75-CB8CE621ABC6}"/>
+                <a16:creationId xmlns:a16="http://schemas.microsoft.com/office/drawing/2014/main" id="{D82966DD-D0C1-45E4-9DFB-D714A89E80C3}"/>
               </a:ext>
             </a:extLst>
           </p:cNvPr>
@@ -3805,7 +3800,7 @@
           <p:cNvPr id="9" name="before-detail">
             <a:extLst xmlns:a="http://schemas.openxmlformats.org/drawingml/2006/main">
               <a:ext uri="{FF2B5EF4-FFF2-40B4-BE49-F238E27FC236}">
-                <a16:creationId xmlns:a16="http://schemas.microsoft.com/office/drawing/2014/main" id="{49798802-3E18-4D0A-BA25-01664618579A}"/>
+                <a16:creationId xmlns:a16="http://schemas.microsoft.com/office/drawing/2014/main" id="{373F4356-B6E3-46EA-BD9E-D3DCECF9DCE3}"/>
               </a:ext>
             </a:extLst>
           </p:cNvPr>
@@ -3863,7 +3858,7 @@
           <p:cNvPr id="10" name="after-quote">
             <a:extLst xmlns:a="http://schemas.openxmlformats.org/drawingml/2006/main">
               <a:ext uri="{FF2B5EF4-FFF2-40B4-BE49-F238E27FC236}">
-                <a16:creationId xmlns:a16="http://schemas.microsoft.com/office/drawing/2014/main" id="{36E101FC-39B0-4DF2-A7F2-10592B8DC9B3}"/>
+                <a16:creationId xmlns:a16="http://schemas.microsoft.com/office/drawing/2014/main" id="{E4F985D8-0A0B-432E-8AD8-E1BD89120258}"/>
               </a:ext>
             </a:extLst>
           </p:cNvPr>
@@ -3921,7 +3916,7 @@
           <p:cNvPr id="11" name="after-detail">
             <a:extLst xmlns:a="http://schemas.openxmlformats.org/drawingml/2006/main">
               <a:ext uri="{FF2B5EF4-FFF2-40B4-BE49-F238E27FC236}">
-                <a16:creationId xmlns:a16="http://schemas.microsoft.com/office/drawing/2014/main" id="{BE92C44A-EA9D-4DE9-B2BB-23749A2EEC5B}"/>
+                <a16:creationId xmlns:a16="http://schemas.microsoft.com/office/drawing/2014/main" id="{26FD4541-2E63-4A20-910C-2B37F2643E81}"/>
               </a:ext>
             </a:extLst>
           </p:cNvPr>
@@ -3979,7 +3974,7 @@
           <p:cNvPr id="12" name="nonclaim">
             <a:extLst xmlns:a="http://schemas.openxmlformats.org/drawingml/2006/main">
               <a:ext uri="{FF2B5EF4-FFF2-40B4-BE49-F238E27FC236}">
-                <a16:creationId xmlns:a16="http://schemas.microsoft.com/office/drawing/2014/main" id="{BFF3FE51-BABF-4D30-8EC3-DC873AFC5FD5}"/>
+                <a16:creationId xmlns:a16="http://schemas.microsoft.com/office/drawing/2014/main" id="{9769CCFC-3E28-4993-8EF3-ED79328C413E}"/>
               </a:ext>
             </a:extLst>
           </p:cNvPr>
@@ -4035,7 +4030,7 @@
     </p:spTree>
     <p:extLst>
       <p:ext uri="{BB962C8B-B14F-4D97-AF65-F5344CB8AC3E}">
-        <p14:creationId xmlns:p14="http://schemas.microsoft.com/office/powerpoint/2010/main" val="975649733"/>
+        <p14:creationId xmlns:p14="http://schemas.microsoft.com/office/powerpoint/2010/main" val="943024225"/>
       </p:ext>
     </p:extLst>
   </p:cSld>
@@ -4066,7 +4061,7 @@
           <p:cNvPr id="10" name="title-4">
             <a:extLst xmlns:a="http://schemas.openxmlformats.org/drawingml/2006/main">
               <a:ext uri="{FF2B5EF4-FFF2-40B4-BE49-F238E27FC236}">
-                <a16:creationId xmlns:a16="http://schemas.microsoft.com/office/drawing/2014/main" id="{FA0B10DC-D94F-4F42-A2E8-A252112A6D37}"/>
+                <a16:creationId xmlns:a16="http://schemas.microsoft.com/office/drawing/2014/main" id="{329AC887-3CD0-4DA4-B295-41039176D7F9}"/>
               </a:ext>
             </a:extLst>
           </p:cNvPr>
@@ -4124,7 +4119,7 @@
           <p:cNvPr id="2" name="accent-4">
             <a:extLst xmlns:a="http://schemas.openxmlformats.org/drawingml/2006/main">
               <a:ext uri="{FF2B5EF4-FFF2-40B4-BE49-F238E27FC236}">
-                <a16:creationId xmlns:a16="http://schemas.microsoft.com/office/drawing/2014/main" id="{D588F7DA-EECD-4733-86B7-2C465A6909BC}"/>
+                <a16:creationId xmlns:a16="http://schemas.microsoft.com/office/drawing/2014/main" id="{22329FCF-C6BA-4D97-97F4-CB83F00AC81C}"/>
               </a:ext>
             </a:extLst>
           </p:cNvPr>
@@ -4157,7 +4152,7 @@
           <p:cNvPr id="3" name="page-4">
             <a:extLst xmlns:a="http://schemas.openxmlformats.org/drawingml/2006/main">
               <a:ext uri="{FF2B5EF4-FFF2-40B4-BE49-F238E27FC236}">
-                <a16:creationId xmlns:a16="http://schemas.microsoft.com/office/drawing/2014/main" id="{6E118536-5B91-4B92-A423-6D689B86D1C9}"/>
+                <a16:creationId xmlns:a16="http://schemas.microsoft.com/office/drawing/2014/main" id="{7AC78C8D-0C24-4F42-B133-4DC77E422081}"/>
               </a:ext>
             </a:extLst>
           </p:cNvPr>
@@ -4215,7 +4210,7 @@
           <p:cNvPr id="4" name="foa-intro">
             <a:extLst xmlns:a="http://schemas.openxmlformats.org/drawingml/2006/main">
               <a:ext uri="{FF2B5EF4-FFF2-40B4-BE49-F238E27FC236}">
-                <a16:creationId xmlns:a16="http://schemas.microsoft.com/office/drawing/2014/main" id="{BC9D30EE-B679-4E33-A996-181978F24971}"/>
+                <a16:creationId xmlns:a16="http://schemas.microsoft.com/office/drawing/2014/main" id="{B55738A7-F210-40AB-BFEA-1816839727BB}"/>
               </a:ext>
             </a:extLst>
           </p:cNvPr>
@@ -4641,7 +4636,7 @@
           <p:cNvPr id="6" name="foa-meaning">
             <a:extLst xmlns:a="http://schemas.openxmlformats.org/drawingml/2006/main">
               <a:ext uri="{FF2B5EF4-FFF2-40B4-BE49-F238E27FC236}">
-                <a16:creationId xmlns:a16="http://schemas.microsoft.com/office/drawing/2014/main" id="{4CED58E4-7031-4293-B9C9-41015B48965B}"/>
+                <a16:creationId xmlns:a16="http://schemas.microsoft.com/office/drawing/2014/main" id="{00D5B417-7AA8-45AE-A95D-5C1D0012EEDB}"/>
               </a:ext>
             </a:extLst>
           </p:cNvPr>
@@ -4674,7 +4669,7 @@
           <p:cNvPr id="7" name="foa-meaning-title">
             <a:extLst xmlns:a="http://schemas.openxmlformats.org/drawingml/2006/main">
               <a:ext uri="{FF2B5EF4-FFF2-40B4-BE49-F238E27FC236}">
-                <a16:creationId xmlns:a16="http://schemas.microsoft.com/office/drawing/2014/main" id="{F87990F0-F826-4D69-8678-2466AB171687}"/>
+                <a16:creationId xmlns:a16="http://schemas.microsoft.com/office/drawing/2014/main" id="{0730E4C7-91F0-4FDA-AC9A-95D7E3DE5C1C}"/>
               </a:ext>
             </a:extLst>
           </p:cNvPr>
@@ -4732,7 +4727,7 @@
           <p:cNvPr id="8" name="foa-meaning-body">
             <a:extLst xmlns:a="http://schemas.openxmlformats.org/drawingml/2006/main">
               <a:ext uri="{FF2B5EF4-FFF2-40B4-BE49-F238E27FC236}">
-                <a16:creationId xmlns:a16="http://schemas.microsoft.com/office/drawing/2014/main" id="{805D596F-8450-423A-9753-AB3FADDB158C}"/>
+                <a16:creationId xmlns:a16="http://schemas.microsoft.com/office/drawing/2014/main" id="{E39B4CBB-1428-4E28-B5E4-6BF1C1C596FD}"/>
               </a:ext>
             </a:extLst>
           </p:cNvPr>
@@ -4874,7 +4869,7 @@
           <p:cNvPr id="9" name="foa-footer">
             <a:extLst xmlns:a="http://schemas.openxmlformats.org/drawingml/2006/main">
               <a:ext uri="{FF2B5EF4-FFF2-40B4-BE49-F238E27FC236}">
-                <a16:creationId xmlns:a16="http://schemas.microsoft.com/office/drawing/2014/main" id="{650E427D-3FAE-458C-B2A0-72B52BB6294D}"/>
+                <a16:creationId xmlns:a16="http://schemas.microsoft.com/office/drawing/2014/main" id="{5309A5AC-6AAC-481A-A174-E395B346A165}"/>
               </a:ext>
             </a:extLst>
           </p:cNvPr>
@@ -4930,7 +4925,7 @@
     </p:spTree>
     <p:extLst>
       <p:ext uri="{BB962C8B-B14F-4D97-AF65-F5344CB8AC3E}">
-        <p14:creationId xmlns:p14="http://schemas.microsoft.com/office/powerpoint/2010/main" val="416766142"/>
+        <p14:creationId xmlns:p14="http://schemas.microsoft.com/office/powerpoint/2010/main" val="2124694604"/>
       </p:ext>
     </p:extLst>
   </p:cSld>
@@ -4961,7 +4956,7 @@
           <p:cNvPr id="23" name="title-5">
             <a:extLst xmlns:a="http://schemas.openxmlformats.org/drawingml/2006/main">
               <a:ext uri="{FF2B5EF4-FFF2-40B4-BE49-F238E27FC236}">
-                <a16:creationId xmlns:a16="http://schemas.microsoft.com/office/drawing/2014/main" id="{5BEAF804-BD07-4D5E-A10E-F030E1FE13D1}"/>
+                <a16:creationId xmlns:a16="http://schemas.microsoft.com/office/drawing/2014/main" id="{570C5577-4EF3-496C-83EF-BB9F575CA359}"/>
               </a:ext>
             </a:extLst>
           </p:cNvPr>
@@ -5019,7 +5014,7 @@
           <p:cNvPr id="2" name="accent-5">
             <a:extLst xmlns:a="http://schemas.openxmlformats.org/drawingml/2006/main">
               <a:ext uri="{FF2B5EF4-FFF2-40B4-BE49-F238E27FC236}">
-                <a16:creationId xmlns:a16="http://schemas.microsoft.com/office/drawing/2014/main" id="{27DA33C6-D65F-472A-97D8-207E57C710AB}"/>
+                <a16:creationId xmlns:a16="http://schemas.microsoft.com/office/drawing/2014/main" id="{B4BF0002-1B5B-4CF5-89AC-F0AFB67702FA}"/>
               </a:ext>
             </a:extLst>
           </p:cNvPr>
@@ -5052,7 +5047,7 @@
           <p:cNvPr id="3" name="page-5">
             <a:extLst xmlns:a="http://schemas.openxmlformats.org/drawingml/2006/main">
               <a:ext uri="{FF2B5EF4-FFF2-40B4-BE49-F238E27FC236}">
-                <a16:creationId xmlns:a16="http://schemas.microsoft.com/office/drawing/2014/main" id="{B6F283AC-C406-40B3-A90F-49CB940211E7}"/>
+                <a16:creationId xmlns:a16="http://schemas.microsoft.com/office/drawing/2014/main" id="{9EC30F9D-8508-44D7-8792-45BA59FA9B90}"/>
               </a:ext>
             </a:extLst>
           </p:cNvPr>
@@ -5110,7 +5105,7 @@
           <p:cNvPr id="4" name="method-value-0">
             <a:extLst xmlns:a="http://schemas.openxmlformats.org/drawingml/2006/main">
               <a:ext uri="{FF2B5EF4-FFF2-40B4-BE49-F238E27FC236}">
-                <a16:creationId xmlns:a16="http://schemas.microsoft.com/office/drawing/2014/main" id="{E5EE9D9B-30B3-4B7E-8727-91777C2CB334}"/>
+                <a16:creationId xmlns:a16="http://schemas.microsoft.com/office/drawing/2014/main" id="{21B765C2-3CFD-4812-9EB5-6DEA3CF80FDA}"/>
               </a:ext>
             </a:extLst>
           </p:cNvPr>
@@ -5168,7 +5163,7 @@
           <p:cNvPr id="5" name="method-label-0">
             <a:extLst xmlns:a="http://schemas.openxmlformats.org/drawingml/2006/main">
               <a:ext uri="{FF2B5EF4-FFF2-40B4-BE49-F238E27FC236}">
-                <a16:creationId xmlns:a16="http://schemas.microsoft.com/office/drawing/2014/main" id="{C19E4E4F-71F5-4B2D-A8A0-7CBF67EDA16E}"/>
+                <a16:creationId xmlns:a16="http://schemas.microsoft.com/office/drawing/2014/main" id="{67E4EBE1-CAC6-465F-B3CE-50429B9A0D60}"/>
               </a:ext>
             </a:extLst>
           </p:cNvPr>
@@ -5226,7 +5221,7 @@
           <p:cNvPr id="6" name="method-value-1">
             <a:extLst xmlns:a="http://schemas.openxmlformats.org/drawingml/2006/main">
               <a:ext uri="{FF2B5EF4-FFF2-40B4-BE49-F238E27FC236}">
-                <a16:creationId xmlns:a16="http://schemas.microsoft.com/office/drawing/2014/main" id="{77813FFB-8EF3-49FB-BAD7-FDCCF992AE5F}"/>
+                <a16:creationId xmlns:a16="http://schemas.microsoft.com/office/drawing/2014/main" id="{04D0BEE7-A048-4FF4-95EF-2A4F2FFFC629}"/>
               </a:ext>
             </a:extLst>
           </p:cNvPr>
@@ -5284,7 +5279,7 @@
           <p:cNvPr id="7" name="method-label-1">
             <a:extLst xmlns:a="http://schemas.openxmlformats.org/drawingml/2006/main">
               <a:ext uri="{FF2B5EF4-FFF2-40B4-BE49-F238E27FC236}">
-                <a16:creationId xmlns:a16="http://schemas.microsoft.com/office/drawing/2014/main" id="{63745760-618D-46F3-8167-8CDCF1FEAD1C}"/>
+                <a16:creationId xmlns:a16="http://schemas.microsoft.com/office/drawing/2014/main" id="{3094BFFD-6423-45B0-BDD4-87994D7672D6}"/>
               </a:ext>
             </a:extLst>
           </p:cNvPr>
@@ -5342,7 +5337,7 @@
           <p:cNvPr id="8" name="method-value-2">
             <a:extLst xmlns:a="http://schemas.openxmlformats.org/drawingml/2006/main">
               <a:ext uri="{FF2B5EF4-FFF2-40B4-BE49-F238E27FC236}">
-                <a16:creationId xmlns:a16="http://schemas.microsoft.com/office/drawing/2014/main" id="{D2E984A1-2016-4C49-9A5C-C3F945708D21}"/>
+                <a16:creationId xmlns:a16="http://schemas.microsoft.com/office/drawing/2014/main" id="{84B63ACD-C1E1-41C1-85FB-CC000508E3E6}"/>
               </a:ext>
             </a:extLst>
           </p:cNvPr>
@@ -5400,7 +5395,7 @@
           <p:cNvPr id="9" name="method-label-2">
             <a:extLst xmlns:a="http://schemas.openxmlformats.org/drawingml/2006/main">
               <a:ext uri="{FF2B5EF4-FFF2-40B4-BE49-F238E27FC236}">
-                <a16:creationId xmlns:a16="http://schemas.microsoft.com/office/drawing/2014/main" id="{7D4556DF-792D-4501-BE20-E864245F3439}"/>
+                <a16:creationId xmlns:a16="http://schemas.microsoft.com/office/drawing/2014/main" id="{0AA7DDFD-C609-48AE-90CA-9E0C83859EF8}"/>
               </a:ext>
             </a:extLst>
           </p:cNvPr>
@@ -5458,7 +5453,7 @@
           <p:cNvPr id="10" name="method-value-3">
             <a:extLst xmlns:a="http://schemas.openxmlformats.org/drawingml/2006/main">
               <a:ext uri="{FF2B5EF4-FFF2-40B4-BE49-F238E27FC236}">
-                <a16:creationId xmlns:a16="http://schemas.microsoft.com/office/drawing/2014/main" id="{09A7C9C6-241B-4469-AFA2-2ED651A1588D}"/>
+                <a16:creationId xmlns:a16="http://schemas.microsoft.com/office/drawing/2014/main" id="{18F48234-8966-4A84-9B98-628A491A3CEF}"/>
               </a:ext>
             </a:extLst>
           </p:cNvPr>
@@ -5516,7 +5511,7 @@
           <p:cNvPr id="11" name="method-label-3">
             <a:extLst xmlns:a="http://schemas.openxmlformats.org/drawingml/2006/main">
               <a:ext uri="{FF2B5EF4-FFF2-40B4-BE49-F238E27FC236}">
-                <a16:creationId xmlns:a16="http://schemas.microsoft.com/office/drawing/2014/main" id="{1FEC82AA-563C-4929-9F6C-C0920BB5A680}"/>
+                <a16:creationId xmlns:a16="http://schemas.microsoft.com/office/drawing/2014/main" id="{8B82A839-54E7-4095-A2D7-98683692A2F1}"/>
               </a:ext>
             </a:extLst>
           </p:cNvPr>
@@ -5574,7 +5569,7 @@
           <p:cNvPr id="12" name="method-divider">
             <a:extLst xmlns:a="http://schemas.openxmlformats.org/drawingml/2006/main">
               <a:ext uri="{FF2B5EF4-FFF2-40B4-BE49-F238E27FC236}">
-                <a16:creationId xmlns:a16="http://schemas.microsoft.com/office/drawing/2014/main" id="{42ADD513-BA52-4E69-B6EA-906EAF8113A2}"/>
+                <a16:creationId xmlns:a16="http://schemas.microsoft.com/office/drawing/2014/main" id="{CF9B430B-6C7D-4D3B-83E4-E17D598C6B6E}"/>
               </a:ext>
             </a:extLst>
           </p:cNvPr>
@@ -5607,7 +5602,7 @@
           <p:cNvPr id="13" name="method-heading-0">
             <a:extLst xmlns:a="http://schemas.openxmlformats.org/drawingml/2006/main">
               <a:ext uri="{FF2B5EF4-FFF2-40B4-BE49-F238E27FC236}">
-                <a16:creationId xmlns:a16="http://schemas.microsoft.com/office/drawing/2014/main" id="{F47D2C98-7693-47D2-BD29-81D58757A7AB}"/>
+                <a16:creationId xmlns:a16="http://schemas.microsoft.com/office/drawing/2014/main" id="{08ACC261-664E-407E-BB61-3BA7681AC738}"/>
               </a:ext>
             </a:extLst>
           </p:cNvPr>
@@ -5665,7 +5660,7 @@
           <p:cNvPr id="14" name="method-body-0">
             <a:extLst xmlns:a="http://schemas.openxmlformats.org/drawingml/2006/main">
               <a:ext uri="{FF2B5EF4-FFF2-40B4-BE49-F238E27FC236}">
-                <a16:creationId xmlns:a16="http://schemas.microsoft.com/office/drawing/2014/main" id="{8DC1B734-03D8-468F-92D3-57F2CC10D95A}"/>
+                <a16:creationId xmlns:a16="http://schemas.microsoft.com/office/drawing/2014/main" id="{F682D7E5-43DA-4772-84C7-513463F1B5B9}"/>
               </a:ext>
             </a:extLst>
           </p:cNvPr>
@@ -5723,7 +5718,7 @@
           <p:cNvPr id="15" name="method-heading-1">
             <a:extLst xmlns:a="http://schemas.openxmlformats.org/drawingml/2006/main">
               <a:ext uri="{FF2B5EF4-FFF2-40B4-BE49-F238E27FC236}">
-                <a16:creationId xmlns:a16="http://schemas.microsoft.com/office/drawing/2014/main" id="{2AAF01DE-C975-4F6D-A629-C80352FDA4F1}"/>
+                <a16:creationId xmlns:a16="http://schemas.microsoft.com/office/drawing/2014/main" id="{7CEAEFD5-597D-4E2D-AA7E-D60A8E096294}"/>
               </a:ext>
             </a:extLst>
           </p:cNvPr>
@@ -5781,7 +5776,7 @@
           <p:cNvPr id="16" name="method-body-1">
             <a:extLst xmlns:a="http://schemas.openxmlformats.org/drawingml/2006/main">
               <a:ext uri="{FF2B5EF4-FFF2-40B4-BE49-F238E27FC236}">
-                <a16:creationId xmlns:a16="http://schemas.microsoft.com/office/drawing/2014/main" id="{0D16E65D-6D68-4926-B585-7A6CB8DA3453}"/>
+                <a16:creationId xmlns:a16="http://schemas.microsoft.com/office/drawing/2014/main" id="{202A6943-7916-48DD-B5F0-0814E0A7F707}"/>
               </a:ext>
             </a:extLst>
           </p:cNvPr>
@@ -5839,7 +5834,7 @@
           <p:cNvPr id="17" name="method-heading-2">
             <a:extLst xmlns:a="http://schemas.openxmlformats.org/drawingml/2006/main">
               <a:ext uri="{FF2B5EF4-FFF2-40B4-BE49-F238E27FC236}">
-                <a16:creationId xmlns:a16="http://schemas.microsoft.com/office/drawing/2014/main" id="{D89AAC85-0B02-473B-BA13-1E98223E6481}"/>
+                <a16:creationId xmlns:a16="http://schemas.microsoft.com/office/drawing/2014/main" id="{9406D064-EA0A-425A-9FBF-2D475A72AFB5}"/>
               </a:ext>
             </a:extLst>
           </p:cNvPr>
@@ -5897,7 +5892,7 @@
           <p:cNvPr id="18" name="method-body-2">
             <a:extLst xmlns:a="http://schemas.openxmlformats.org/drawingml/2006/main">
               <a:ext uri="{FF2B5EF4-FFF2-40B4-BE49-F238E27FC236}">
-                <a16:creationId xmlns:a16="http://schemas.microsoft.com/office/drawing/2014/main" id="{E822696E-1ADA-40BD-B77C-8A7E97B18E7B}"/>
+                <a16:creationId xmlns:a16="http://schemas.microsoft.com/office/drawing/2014/main" id="{6DCA607E-135A-4387-B832-E71D94FE746F}"/>
               </a:ext>
             </a:extLst>
           </p:cNvPr>
@@ -5955,7 +5950,7 @@
           <p:cNvPr id="19" name="method-heading-3">
             <a:extLst xmlns:a="http://schemas.openxmlformats.org/drawingml/2006/main">
               <a:ext uri="{FF2B5EF4-FFF2-40B4-BE49-F238E27FC236}">
-                <a16:creationId xmlns:a16="http://schemas.microsoft.com/office/drawing/2014/main" id="{D1BBBC6C-516B-4D70-AF9D-B25309D9A5B6}"/>
+                <a16:creationId xmlns:a16="http://schemas.microsoft.com/office/drawing/2014/main" id="{A3885146-A40D-4158-9297-D58627042011}"/>
               </a:ext>
             </a:extLst>
           </p:cNvPr>
@@ -6013,7 +6008,7 @@
           <p:cNvPr id="20" name="method-body-3">
             <a:extLst xmlns:a="http://schemas.openxmlformats.org/drawingml/2006/main">
               <a:ext uri="{FF2B5EF4-FFF2-40B4-BE49-F238E27FC236}">
-                <a16:creationId xmlns:a16="http://schemas.microsoft.com/office/drawing/2014/main" id="{A1DAC946-7898-4CFE-BF81-9634E1373174}"/>
+                <a16:creationId xmlns:a16="http://schemas.microsoft.com/office/drawing/2014/main" id="{E0D50747-7C97-482A-A5AC-3E2175F4C176}"/>
               </a:ext>
             </a:extLst>
           </p:cNvPr>
@@ -6071,7 +6066,7 @@
           <p:cNvPr id="21" name="method-heading-4">
             <a:extLst xmlns:a="http://schemas.openxmlformats.org/drawingml/2006/main">
               <a:ext uri="{FF2B5EF4-FFF2-40B4-BE49-F238E27FC236}">
-                <a16:creationId xmlns:a16="http://schemas.microsoft.com/office/drawing/2014/main" id="{36FF3C7E-F8E1-4666-BA9D-4CD175D896B0}"/>
+                <a16:creationId xmlns:a16="http://schemas.microsoft.com/office/drawing/2014/main" id="{AEDFFFEE-B62B-4402-B7D1-2C127E63A01C}"/>
               </a:ext>
             </a:extLst>
           </p:cNvPr>
@@ -6129,7 +6124,7 @@
           <p:cNvPr id="22" name="method-body-4">
             <a:extLst xmlns:a="http://schemas.openxmlformats.org/drawingml/2006/main">
               <a:ext uri="{FF2B5EF4-FFF2-40B4-BE49-F238E27FC236}">
-                <a16:creationId xmlns:a16="http://schemas.microsoft.com/office/drawing/2014/main" id="{3121FAC5-CA11-4DC1-9C0F-A9442B2F04B3}"/>
+                <a16:creationId xmlns:a16="http://schemas.microsoft.com/office/drawing/2014/main" id="{4327FD3C-4948-4086-ACAD-3423DE8921E6}"/>
               </a:ext>
             </a:extLst>
           </p:cNvPr>
@@ -6185,7 +6180,7 @@
     </p:spTree>
     <p:extLst>
       <p:ext uri="{BB962C8B-B14F-4D97-AF65-F5344CB8AC3E}">
-        <p14:creationId xmlns:p14="http://schemas.microsoft.com/office/powerpoint/2010/main" val="1958890155"/>
+        <p14:creationId xmlns:p14="http://schemas.microsoft.com/office/powerpoint/2010/main" val="1440146981"/>
       </p:ext>
     </p:extLst>
   </p:cSld>
@@ -6216,7 +6211,7 @@
           <p:cNvPr id="12" name="title-6">
             <a:extLst xmlns:a="http://schemas.openxmlformats.org/drawingml/2006/main">
               <a:ext uri="{FF2B5EF4-FFF2-40B4-BE49-F238E27FC236}">
-                <a16:creationId xmlns:a16="http://schemas.microsoft.com/office/drawing/2014/main" id="{85E066B6-1616-4D2F-B216-3A2E9183910B}"/>
+                <a16:creationId xmlns:a16="http://schemas.microsoft.com/office/drawing/2014/main" id="{BF12BE70-0079-45B7-A04D-E39EB89C7A20}"/>
               </a:ext>
             </a:extLst>
           </p:cNvPr>
@@ -6274,7 +6269,7 @@
           <p:cNvPr id="2" name="accent-6">
             <a:extLst xmlns:a="http://schemas.openxmlformats.org/drawingml/2006/main">
               <a:ext uri="{FF2B5EF4-FFF2-40B4-BE49-F238E27FC236}">
-                <a16:creationId xmlns:a16="http://schemas.microsoft.com/office/drawing/2014/main" id="{A9628CFD-B985-4B72-9C6C-5DE74D35DA2F}"/>
+                <a16:creationId xmlns:a16="http://schemas.microsoft.com/office/drawing/2014/main" id="{2FC58524-73EA-45E3-9CF4-260196C97484}"/>
               </a:ext>
             </a:extLst>
           </p:cNvPr>
@@ -6307,7 +6302,7 @@
           <p:cNvPr id="3" name="page-6">
             <a:extLst xmlns:a="http://schemas.openxmlformats.org/drawingml/2006/main">
               <a:ext uri="{FF2B5EF4-FFF2-40B4-BE49-F238E27FC236}">
-                <a16:creationId xmlns:a16="http://schemas.microsoft.com/office/drawing/2014/main" id="{A8B558B7-74B1-43CA-891A-89328424CF9D}"/>
+                <a16:creationId xmlns:a16="http://schemas.microsoft.com/office/drawing/2014/main" id="{2AECA334-7B6B-4ABE-9FB5-FF14DA32E7FE}"/>
               </a:ext>
             </a:extLst>
           </p:cNvPr>
@@ -6372,7 +6367,7 @@
         </p:xfrm>
         <a:graphic xmlns:a="http://schemas.openxmlformats.org/drawingml/2006/main">
           <a:graphicData uri="http://schemas.openxmlformats.org/drawingml/2006/chart">
-            <c:chart xmlns:r="http://schemas.openxmlformats.org/officeDocument/2006/relationships" xmlns:c="http://schemas.openxmlformats.org/drawingml/2006/chart" r:id="Rb8724a6d986c49dd"/>
+            <c:chart xmlns:r="http://schemas.openxmlformats.org/officeDocument/2006/relationships" xmlns:c="http://schemas.openxmlformats.org/drawingml/2006/chart" r:id="R96ddb2a546d24bfb"/>
           </a:graphicData>
         </a:graphic>
       </p:graphicFrame>
@@ -6381,7 +6376,7 @@
           <p:cNvPr id="5" name="evidence-side">
             <a:extLst xmlns:a="http://schemas.openxmlformats.org/drawingml/2006/main">
               <a:ext uri="{FF2B5EF4-FFF2-40B4-BE49-F238E27FC236}">
-                <a16:creationId xmlns:a16="http://schemas.microsoft.com/office/drawing/2014/main" id="{C1A754AA-4828-4463-97D2-0FB2643E76E9}"/>
+                <a16:creationId xmlns:a16="http://schemas.microsoft.com/office/drawing/2014/main" id="{65DE15B2-5818-40F1-9D44-3C7CB264D811}"/>
               </a:ext>
             </a:extLst>
           </p:cNvPr>
@@ -6414,7 +6409,7 @@
           <p:cNvPr id="6" name="evidence-side-title">
             <a:extLst xmlns:a="http://schemas.openxmlformats.org/drawingml/2006/main">
               <a:ext uri="{FF2B5EF4-FFF2-40B4-BE49-F238E27FC236}">
-                <a16:creationId xmlns:a16="http://schemas.microsoft.com/office/drawing/2014/main" id="{607D54E7-AA66-48C0-ADD8-DC046F4316BB}"/>
+                <a16:creationId xmlns:a16="http://schemas.microsoft.com/office/drawing/2014/main" id="{52283FF4-8C50-4071-801C-86D35AEB7310}"/>
               </a:ext>
             </a:extLst>
           </p:cNvPr>
@@ -6472,7 +6467,7 @@
           <p:cNvPr id="7" name="evidence-reliability">
             <a:extLst xmlns:a="http://schemas.openxmlformats.org/drawingml/2006/main">
               <a:ext uri="{FF2B5EF4-FFF2-40B4-BE49-F238E27FC236}">
-                <a16:creationId xmlns:a16="http://schemas.microsoft.com/office/drawing/2014/main" id="{E5BE27C4-46E3-495A-9054-FEA7724F3B2E}"/>
+                <a16:creationId xmlns:a16="http://schemas.microsoft.com/office/drawing/2014/main" id="{A3EA5A18-B555-4482-B61E-8D0873DEC38F}"/>
               </a:ext>
             </a:extLst>
           </p:cNvPr>
@@ -6530,7 +6525,7 @@
           <p:cNvPr id="8" name="evidence-icc">
             <a:extLst xmlns:a="http://schemas.openxmlformats.org/drawingml/2006/main">
               <a:ext uri="{FF2B5EF4-FFF2-40B4-BE49-F238E27FC236}">
-                <a16:creationId xmlns:a16="http://schemas.microsoft.com/office/drawing/2014/main" id="{2BF858AB-8EAA-4658-869D-A245CD403380}"/>
+                <a16:creationId xmlns:a16="http://schemas.microsoft.com/office/drawing/2014/main" id="{E09CD1D0-189B-40CB-BAFF-D3D23463665A}"/>
               </a:ext>
             </a:extLst>
           </p:cNvPr>
@@ -6588,7 +6583,7 @@
           <p:cNvPr id="9" name="evidence-single">
             <a:extLst xmlns:a="http://schemas.openxmlformats.org/drawingml/2006/main">
               <a:ext uri="{FF2B5EF4-FFF2-40B4-BE49-F238E27FC236}">
-                <a16:creationId xmlns:a16="http://schemas.microsoft.com/office/drawing/2014/main" id="{EFD63D14-AD7C-44A8-A91E-F1E0A5F9BDA7}"/>
+                <a16:creationId xmlns:a16="http://schemas.microsoft.com/office/drawing/2014/main" id="{2446E6DA-66A5-4DC2-9E7A-94FF4EA2E842}"/>
               </a:ext>
             </a:extLst>
           </p:cNvPr>
@@ -6669,7 +6664,7 @@
           <p:cNvPr id="10" name="evidence-side-rule">
             <a:extLst xmlns:a="http://schemas.openxmlformats.org/drawingml/2006/main">
               <a:ext uri="{FF2B5EF4-FFF2-40B4-BE49-F238E27FC236}">
-                <a16:creationId xmlns:a16="http://schemas.microsoft.com/office/drawing/2014/main" id="{68D7DF45-F669-484C-9A6B-F445994E4DFC}"/>
+                <a16:creationId xmlns:a16="http://schemas.microsoft.com/office/drawing/2014/main" id="{04E569B1-5C62-43C5-95E1-2BD1E566E70A}"/>
               </a:ext>
             </a:extLst>
           </p:cNvPr>
@@ -6702,7 +6697,7 @@
           <p:cNvPr id="11" name="evidence-health">
             <a:extLst xmlns:a="http://schemas.openxmlformats.org/drawingml/2006/main">
               <a:ext uri="{FF2B5EF4-FFF2-40B4-BE49-F238E27FC236}">
-                <a16:creationId xmlns:a16="http://schemas.microsoft.com/office/drawing/2014/main" id="{E18175A0-38F8-44D8-8D74-2E8A1C33A5A9}"/>
+                <a16:creationId xmlns:a16="http://schemas.microsoft.com/office/drawing/2014/main" id="{ABC35BE9-E8B2-4557-A88B-1302796E8AE1}"/>
               </a:ext>
             </a:extLst>
           </p:cNvPr>
@@ -6758,7 +6753,7 @@
     </p:spTree>
     <p:extLst>
       <p:ext uri="{BB962C8B-B14F-4D97-AF65-F5344CB8AC3E}">
-        <p14:creationId xmlns:p14="http://schemas.microsoft.com/office/powerpoint/2010/main" val="1918578747"/>
+        <p14:creationId xmlns:p14="http://schemas.microsoft.com/office/powerpoint/2010/main" val="971520292"/>
       </p:ext>
     </p:extLst>
   </p:cSld>
@@ -6789,7 +6784,7 @@
           <p:cNvPr id="21" name="title-7">
             <a:extLst xmlns:a="http://schemas.openxmlformats.org/drawingml/2006/main">
               <a:ext uri="{FF2B5EF4-FFF2-40B4-BE49-F238E27FC236}">
-                <a16:creationId xmlns:a16="http://schemas.microsoft.com/office/drawing/2014/main" id="{C7AC3AF3-D51E-4028-B217-416A991D45BF}"/>
+                <a16:creationId xmlns:a16="http://schemas.microsoft.com/office/drawing/2014/main" id="{E3E3D0A4-60CF-4384-920A-220FFCB3FE2D}"/>
               </a:ext>
             </a:extLst>
           </p:cNvPr>
@@ -6847,7 +6842,7 @@
           <p:cNvPr id="2" name="accent-7">
             <a:extLst xmlns:a="http://schemas.openxmlformats.org/drawingml/2006/main">
               <a:ext uri="{FF2B5EF4-FFF2-40B4-BE49-F238E27FC236}">
-                <a16:creationId xmlns:a16="http://schemas.microsoft.com/office/drawing/2014/main" id="{DC85D426-3F31-4924-A592-F7EA262BC064}"/>
+                <a16:creationId xmlns:a16="http://schemas.microsoft.com/office/drawing/2014/main" id="{15B706BD-1512-4858-9556-58821F222F40}"/>
               </a:ext>
             </a:extLst>
           </p:cNvPr>
@@ -6880,7 +6875,7 @@
           <p:cNvPr id="3" name="page-7">
             <a:extLst xmlns:a="http://schemas.openxmlformats.org/drawingml/2006/main">
               <a:ext uri="{FF2B5EF4-FFF2-40B4-BE49-F238E27FC236}">
-                <a16:creationId xmlns:a16="http://schemas.microsoft.com/office/drawing/2014/main" id="{D9D8C3FD-1A1A-411F-8788-C13BC86384B9}"/>
+                <a16:creationId xmlns:a16="http://schemas.microsoft.com/office/drawing/2014/main" id="{AFB5BFEA-D43B-4E81-9568-C2B0BF3AAB15}"/>
               </a:ext>
             </a:extLst>
           </p:cNvPr>
@@ -6938,7 +6933,7 @@
           <p:cNvPr id="4" name="eirb-label">
             <a:extLst xmlns:a="http://schemas.openxmlformats.org/drawingml/2006/main">
               <a:ext uri="{FF2B5EF4-FFF2-40B4-BE49-F238E27FC236}">
-                <a16:creationId xmlns:a16="http://schemas.microsoft.com/office/drawing/2014/main" id="{E3250873-D331-42D5-95AD-BFF91D547D80}"/>
+                <a16:creationId xmlns:a16="http://schemas.microsoft.com/office/drawing/2014/main" id="{5AC32742-9D80-4961-B51F-7AF6C5975C80}"/>
               </a:ext>
             </a:extLst>
           </p:cNvPr>
@@ -6996,7 +6991,7 @@
           <p:cNvPr id="5" name="eirb-status">
             <a:extLst xmlns:a="http://schemas.openxmlformats.org/drawingml/2006/main">
               <a:ext uri="{FF2B5EF4-FFF2-40B4-BE49-F238E27FC236}">
-                <a16:creationId xmlns:a16="http://schemas.microsoft.com/office/drawing/2014/main" id="{FE0ADA09-E0DD-4A8A-B904-407843160D74}"/>
+                <a16:creationId xmlns:a16="http://schemas.microsoft.com/office/drawing/2014/main" id="{7D078D0F-0F4D-4FC9-8D64-6040F7B77B82}"/>
               </a:ext>
             </a:extLst>
           </p:cNvPr>
@@ -7054,7 +7049,7 @@
           <p:cNvPr id="6" name="eirb-date">
             <a:extLst xmlns:a="http://schemas.openxmlformats.org/drawingml/2006/main">
               <a:ext uri="{FF2B5EF4-FFF2-40B4-BE49-F238E27FC236}">
-                <a16:creationId xmlns:a16="http://schemas.microsoft.com/office/drawing/2014/main" id="{66B3C927-777D-44EE-965E-CADFB5364CC1}"/>
+                <a16:creationId xmlns:a16="http://schemas.microsoft.com/office/drawing/2014/main" id="{AF7B9E1D-92E3-406C-8CA1-261CB5115CDC}"/>
               </a:ext>
             </a:extLst>
           </p:cNvPr>
@@ -7112,7 +7107,7 @@
           <p:cNvPr id="7" name="eirb-scope">
             <a:extLst xmlns:a="http://schemas.openxmlformats.org/drawingml/2006/main">
               <a:ext uri="{FF2B5EF4-FFF2-40B4-BE49-F238E27FC236}">
-                <a16:creationId xmlns:a16="http://schemas.microsoft.com/office/drawing/2014/main" id="{38DA0257-C68E-4FAC-B7E9-035E44ADB329}"/>
+                <a16:creationId xmlns:a16="http://schemas.microsoft.com/office/drawing/2014/main" id="{C18CE06A-4377-4DF1-A847-FDB026F7F41D}"/>
               </a:ext>
             </a:extLst>
           </p:cNvPr>
@@ -7170,7 +7165,7 @@
           <p:cNvPr id="8" name="eirb-separator">
             <a:extLst xmlns:a="http://schemas.openxmlformats.org/drawingml/2006/main">
               <a:ext uri="{FF2B5EF4-FFF2-40B4-BE49-F238E27FC236}">
-                <a16:creationId xmlns:a16="http://schemas.microsoft.com/office/drawing/2014/main" id="{61A52A0D-2F45-4E89-9B37-9A1FD6E264FB}"/>
+                <a16:creationId xmlns:a16="http://schemas.microsoft.com/office/drawing/2014/main" id="{C5737FEB-DAB7-40ED-9CA3-9C0BC747905A}"/>
               </a:ext>
             </a:extLst>
           </p:cNvPr>
@@ -7203,7 +7198,7 @@
           <p:cNvPr id="9" name="check-mark-168">
             <a:extLst xmlns:a="http://schemas.openxmlformats.org/drawingml/2006/main">
               <a:ext uri="{FF2B5EF4-FFF2-40B4-BE49-F238E27FC236}">
-                <a16:creationId xmlns:a16="http://schemas.microsoft.com/office/drawing/2014/main" id="{4A178979-9007-4340-9001-2A543521EDE4}"/>
+                <a16:creationId xmlns:a16="http://schemas.microsoft.com/office/drawing/2014/main" id="{8E1FF5BC-86C8-4E7B-8D05-2181F05A8F92}"/>
               </a:ext>
             </a:extLst>
           </p:cNvPr>
@@ -7236,7 +7231,7 @@
           <p:cNvPr id="10" name="check-label-168">
             <a:extLst xmlns:a="http://schemas.openxmlformats.org/drawingml/2006/main">
               <a:ext uri="{FF2B5EF4-FFF2-40B4-BE49-F238E27FC236}">
-                <a16:creationId xmlns:a16="http://schemas.microsoft.com/office/drawing/2014/main" id="{FB95645D-BBAA-4FFD-A450-E6D0E97308C5}"/>
+                <a16:creationId xmlns:a16="http://schemas.microsoft.com/office/drawing/2014/main" id="{EFFF79C1-84DF-4638-B9D5-293C0F38A134}"/>
               </a:ext>
             </a:extLst>
           </p:cNvPr>
@@ -7294,7 +7289,7 @@
           <p:cNvPr id="11" name="check-detail-168">
             <a:extLst xmlns:a="http://schemas.openxmlformats.org/drawingml/2006/main">
               <a:ext uri="{FF2B5EF4-FFF2-40B4-BE49-F238E27FC236}">
-                <a16:creationId xmlns:a16="http://schemas.microsoft.com/office/drawing/2014/main" id="{54010115-1863-4993-AD13-227E7271B145}"/>
+                <a16:creationId xmlns:a16="http://schemas.microsoft.com/office/drawing/2014/main" id="{99C87D80-FF76-4A3C-9677-050222B2FC18}"/>
               </a:ext>
             </a:extLst>
           </p:cNvPr>
@@ -7352,7 +7347,7 @@
           <p:cNvPr id="12" name="check-mark-278">
             <a:extLst xmlns:a="http://schemas.openxmlformats.org/drawingml/2006/main">
               <a:ext uri="{FF2B5EF4-FFF2-40B4-BE49-F238E27FC236}">
-                <a16:creationId xmlns:a16="http://schemas.microsoft.com/office/drawing/2014/main" id="{B2881C09-BC74-4CB8-9F09-435E15A068D0}"/>
+                <a16:creationId xmlns:a16="http://schemas.microsoft.com/office/drawing/2014/main" id="{E57C6E7C-1FC8-4D44-8439-F8E7BC2E0E8E}"/>
               </a:ext>
             </a:extLst>
           </p:cNvPr>
@@ -7385,7 +7380,7 @@
           <p:cNvPr id="13" name="check-label-278">
             <a:extLst xmlns:a="http://schemas.openxmlformats.org/drawingml/2006/main">
               <a:ext uri="{FF2B5EF4-FFF2-40B4-BE49-F238E27FC236}">
-                <a16:creationId xmlns:a16="http://schemas.microsoft.com/office/drawing/2014/main" id="{5ED1BBAF-6D07-4A05-B4C2-F46D511ACA52}"/>
+                <a16:creationId xmlns:a16="http://schemas.microsoft.com/office/drawing/2014/main" id="{752E0710-2ED8-45C0-A878-9247EF2BE449}"/>
               </a:ext>
             </a:extLst>
           </p:cNvPr>
@@ -7443,7 +7438,7 @@
           <p:cNvPr id="14" name="check-detail-278">
             <a:extLst xmlns:a="http://schemas.openxmlformats.org/drawingml/2006/main">
               <a:ext uri="{FF2B5EF4-FFF2-40B4-BE49-F238E27FC236}">
-                <a16:creationId xmlns:a16="http://schemas.microsoft.com/office/drawing/2014/main" id="{539A8067-B2F2-4904-A985-712FE955EFA4}"/>
+                <a16:creationId xmlns:a16="http://schemas.microsoft.com/office/drawing/2014/main" id="{6986FAF1-75F0-44C0-B4DE-B92F1A144BDF}"/>
               </a:ext>
             </a:extLst>
           </p:cNvPr>
@@ -7501,7 +7496,7 @@
           <p:cNvPr id="15" name="check-mark-410">
             <a:extLst xmlns:a="http://schemas.openxmlformats.org/drawingml/2006/main">
               <a:ext uri="{FF2B5EF4-FFF2-40B4-BE49-F238E27FC236}">
-                <a16:creationId xmlns:a16="http://schemas.microsoft.com/office/drawing/2014/main" id="{06273DC1-C71A-4DCE-84D1-EF4C3E6D8AC5}"/>
+                <a16:creationId xmlns:a16="http://schemas.microsoft.com/office/drawing/2014/main" id="{5F27DB8E-63BE-46B3-83A4-A0EE50597FCE}"/>
               </a:ext>
             </a:extLst>
           </p:cNvPr>
@@ -7534,7 +7529,7 @@
           <p:cNvPr id="16" name="check-label-410">
             <a:extLst xmlns:a="http://schemas.openxmlformats.org/drawingml/2006/main">
               <a:ext uri="{FF2B5EF4-FFF2-40B4-BE49-F238E27FC236}">
-                <a16:creationId xmlns:a16="http://schemas.microsoft.com/office/drawing/2014/main" id="{F74254B7-0520-493E-A0CC-6CD283862DA8}"/>
+                <a16:creationId xmlns:a16="http://schemas.microsoft.com/office/drawing/2014/main" id="{91A37CE0-2179-493F-B15A-B56EE8FC170B}"/>
               </a:ext>
             </a:extLst>
           </p:cNvPr>
@@ -7592,7 +7587,7 @@
           <p:cNvPr id="17" name="check-detail-410">
             <a:extLst xmlns:a="http://schemas.openxmlformats.org/drawingml/2006/main">
               <a:ext uri="{FF2B5EF4-FFF2-40B4-BE49-F238E27FC236}">
-                <a16:creationId xmlns:a16="http://schemas.microsoft.com/office/drawing/2014/main" id="{47438A88-9305-4043-A8F0-54B2E0D7B442}"/>
+                <a16:creationId xmlns:a16="http://schemas.microsoft.com/office/drawing/2014/main" id="{D6D8CA15-FC49-4C59-9BE0-3EE2A9095CDB}"/>
               </a:ext>
             </a:extLst>
           </p:cNvPr>
@@ -7650,7 +7645,7 @@
           <p:cNvPr id="18" name="check-mark-542">
             <a:extLst xmlns:a="http://schemas.openxmlformats.org/drawingml/2006/main">
               <a:ext uri="{FF2B5EF4-FFF2-40B4-BE49-F238E27FC236}">
-                <a16:creationId xmlns:a16="http://schemas.microsoft.com/office/drawing/2014/main" id="{D56CF3AD-A25A-4B40-9443-C921462CE0AD}"/>
+                <a16:creationId xmlns:a16="http://schemas.microsoft.com/office/drawing/2014/main" id="{4152E3CF-5D00-4BE9-BA2F-000FBE7AAA09}"/>
               </a:ext>
             </a:extLst>
           </p:cNvPr>
@@ -7683,7 +7678,7 @@
           <p:cNvPr id="19" name="check-label-542">
             <a:extLst xmlns:a="http://schemas.openxmlformats.org/drawingml/2006/main">
               <a:ext uri="{FF2B5EF4-FFF2-40B4-BE49-F238E27FC236}">
-                <a16:creationId xmlns:a16="http://schemas.microsoft.com/office/drawing/2014/main" id="{71BC5740-05D3-415B-9199-CC28EE363DA9}"/>
+                <a16:creationId xmlns:a16="http://schemas.microsoft.com/office/drawing/2014/main" id="{83F4EC62-7DA5-4FD6-8D5E-F303E7118BD1}"/>
               </a:ext>
             </a:extLst>
           </p:cNvPr>
@@ -7741,7 +7736,7 @@
           <p:cNvPr id="20" name="check-detail-542">
             <a:extLst xmlns:a="http://schemas.openxmlformats.org/drawingml/2006/main">
               <a:ext uri="{FF2B5EF4-FFF2-40B4-BE49-F238E27FC236}">
-                <a16:creationId xmlns:a16="http://schemas.microsoft.com/office/drawing/2014/main" id="{76631DC0-4C47-4BCE-87FF-2AD8806C58CD}"/>
+                <a16:creationId xmlns:a16="http://schemas.microsoft.com/office/drawing/2014/main" id="{452ACE41-485F-43E4-9294-79CE20771696}"/>
               </a:ext>
             </a:extLst>
           </p:cNvPr>
@@ -7797,7 +7792,7 @@
     </p:spTree>
     <p:extLst>
       <p:ext uri="{BB962C8B-B14F-4D97-AF65-F5344CB8AC3E}">
-        <p14:creationId xmlns:p14="http://schemas.microsoft.com/office/powerpoint/2010/main" val="926901090"/>
+        <p14:creationId xmlns:p14="http://schemas.microsoft.com/office/powerpoint/2010/main" val="2121288995"/>
       </p:ext>
     </p:extLst>
   </p:cSld>
@@ -7825,10 +7820,10 @@
       </p:grpSpPr>
       <p:sp>
         <p:nvSpPr>
-          <p:cNvPr id="21" name="title-8">
-            <a:extLst xmlns:a="http://schemas.openxmlformats.org/drawingml/2006/main">
-              <a:ext uri="{FF2B5EF4-FFF2-40B4-BE49-F238E27FC236}">
-                <a16:creationId xmlns:a16="http://schemas.microsoft.com/office/drawing/2014/main" id="{5AA876EA-6AE1-4CA5-AEBF-82BBCB1E8B2E}"/>
+          <p:cNvPr id="18" name="title-8">
+            <a:extLst xmlns:a="http://schemas.openxmlformats.org/drawingml/2006/main">
+              <a:ext uri="{FF2B5EF4-FFF2-40B4-BE49-F238E27FC236}">
+                <a16:creationId xmlns:a16="http://schemas.microsoft.com/office/drawing/2014/main" id="{1F375E62-5D4C-4036-A12A-A0DDCD63DD79}"/>
               </a:ext>
             </a:extLst>
           </p:cNvPr>
@@ -7886,7 +7881,7 @@
           <p:cNvPr id="2" name="accent-8">
             <a:extLst xmlns:a="http://schemas.openxmlformats.org/drawingml/2006/main">
               <a:ext uri="{FF2B5EF4-FFF2-40B4-BE49-F238E27FC236}">
-                <a16:creationId xmlns:a16="http://schemas.microsoft.com/office/drawing/2014/main" id="{0DC45D57-7DEB-4E28-A739-DEA09AD6BBBF}"/>
+                <a16:creationId xmlns:a16="http://schemas.microsoft.com/office/drawing/2014/main" id="{D2651725-01A5-41FE-A8A4-5BBD184836AF}"/>
               </a:ext>
             </a:extLst>
           </p:cNvPr>
@@ -7919,7 +7914,7 @@
           <p:cNvPr id="3" name="page-8">
             <a:extLst xmlns:a="http://schemas.openxmlformats.org/drawingml/2006/main">
               <a:ext uri="{FF2B5EF4-FFF2-40B4-BE49-F238E27FC236}">
-                <a16:creationId xmlns:a16="http://schemas.microsoft.com/office/drawing/2014/main" id="{FF5092CE-CB48-4A57-9366-6391F8A96965}"/>
+                <a16:creationId xmlns:a16="http://schemas.microsoft.com/office/drawing/2014/main" id="{D9A92019-37AC-424A-8C0B-10015EB9557F}"/>
               </a:ext>
             </a:extLst>
           </p:cNvPr>
@@ -7977,7 +7972,7 @@
           <p:cNvPr id="4" name="readiness-panel-0">
             <a:extLst xmlns:a="http://schemas.openxmlformats.org/drawingml/2006/main">
               <a:ext uri="{FF2B5EF4-FFF2-40B4-BE49-F238E27FC236}">
-                <a16:creationId xmlns:a16="http://schemas.microsoft.com/office/drawing/2014/main" id="{5FDB79F3-6A48-49A5-896A-63DA060731CE}"/>
+                <a16:creationId xmlns:a16="http://schemas.microsoft.com/office/drawing/2014/main" id="{F5187682-0F63-4B7E-9589-B790663B7E0F}"/>
               </a:ext>
             </a:extLst>
           </p:cNvPr>
@@ -8010,7 +8005,7 @@
           <p:cNvPr id="5" name="readiness-stat-0">
             <a:extLst xmlns:a="http://schemas.openxmlformats.org/drawingml/2006/main">
               <a:ext uri="{FF2B5EF4-FFF2-40B4-BE49-F238E27FC236}">
-                <a16:creationId xmlns:a16="http://schemas.microsoft.com/office/drawing/2014/main" id="{B9DDF80D-8752-488A-A0CB-63C4C93D4534}"/>
+                <a16:creationId xmlns:a16="http://schemas.microsoft.com/office/drawing/2014/main" id="{20931E72-F8F9-40B5-9A15-ACD83965AECE}"/>
               </a:ext>
             </a:extLst>
           </p:cNvPr>
@@ -8068,7 +8063,7 @@
           <p:cNvPr id="6" name="readiness-label-0">
             <a:extLst xmlns:a="http://schemas.openxmlformats.org/drawingml/2006/main">
               <a:ext uri="{FF2B5EF4-FFF2-40B4-BE49-F238E27FC236}">
-                <a16:creationId xmlns:a16="http://schemas.microsoft.com/office/drawing/2014/main" id="{B211C2CC-E28B-401C-B7AF-82BEE08C2F5C}"/>
+                <a16:creationId xmlns:a16="http://schemas.microsoft.com/office/drawing/2014/main" id="{64758D49-9C92-4FEC-B576-E98BB3FB759A}"/>
               </a:ext>
             </a:extLst>
           </p:cNvPr>
@@ -8126,7 +8121,7 @@
           <p:cNvPr id="7" name="readiness-note-0">
             <a:extLst xmlns:a="http://schemas.openxmlformats.org/drawingml/2006/main">
               <a:ext uri="{FF2B5EF4-FFF2-40B4-BE49-F238E27FC236}">
-                <a16:creationId xmlns:a16="http://schemas.microsoft.com/office/drawing/2014/main" id="{774C0638-9222-4011-B76E-2AF0FF3F0741}"/>
+                <a16:creationId xmlns:a16="http://schemas.microsoft.com/office/drawing/2014/main" id="{ACCE6B64-F1D0-48B7-B8D0-17FDA267BE18}"/>
               </a:ext>
             </a:extLst>
           </p:cNvPr>
@@ -8184,7 +8179,7 @@
           <p:cNvPr id="8" name="readiness-panel-1">
             <a:extLst xmlns:a="http://schemas.openxmlformats.org/drawingml/2006/main">
               <a:ext uri="{FF2B5EF4-FFF2-40B4-BE49-F238E27FC236}">
-                <a16:creationId xmlns:a16="http://schemas.microsoft.com/office/drawing/2014/main" id="{512BFC83-09DD-480A-8AFA-CA20E809FAA6}"/>
+                <a16:creationId xmlns:a16="http://schemas.microsoft.com/office/drawing/2014/main" id="{355F0F54-A1C2-4CE9-8787-5015195D4F7C}"/>
               </a:ext>
             </a:extLst>
           </p:cNvPr>
@@ -8217,7 +8212,7 @@
           <p:cNvPr id="9" name="readiness-stat-1">
             <a:extLst xmlns:a="http://schemas.openxmlformats.org/drawingml/2006/main">
               <a:ext uri="{FF2B5EF4-FFF2-40B4-BE49-F238E27FC236}">
-                <a16:creationId xmlns:a16="http://schemas.microsoft.com/office/drawing/2014/main" id="{B9B2CE8B-7C79-4DEB-90FB-FE2CDB396350}"/>
+                <a16:creationId xmlns:a16="http://schemas.microsoft.com/office/drawing/2014/main" id="{2AC9F51C-F8EE-4CE5-A3B2-8AADFE52E5EB}"/>
               </a:ext>
             </a:extLst>
           </p:cNvPr>
@@ -8275,7 +8270,7 @@
           <p:cNvPr id="10" name="readiness-label-1">
             <a:extLst xmlns:a="http://schemas.openxmlformats.org/drawingml/2006/main">
               <a:ext uri="{FF2B5EF4-FFF2-40B4-BE49-F238E27FC236}">
-                <a16:creationId xmlns:a16="http://schemas.microsoft.com/office/drawing/2014/main" id="{5A01DBB0-4FE7-4244-9424-ABC377D7E6A2}"/>
+                <a16:creationId xmlns:a16="http://schemas.microsoft.com/office/drawing/2014/main" id="{B4D801A4-4FD5-428D-ADB4-C6E29D1F4042}"/>
               </a:ext>
             </a:extLst>
           </p:cNvPr>
@@ -8333,7 +8328,7 @@
           <p:cNvPr id="11" name="readiness-note-1">
             <a:extLst xmlns:a="http://schemas.openxmlformats.org/drawingml/2006/main">
               <a:ext uri="{FF2B5EF4-FFF2-40B4-BE49-F238E27FC236}">
-                <a16:creationId xmlns:a16="http://schemas.microsoft.com/office/drawing/2014/main" id="{F3A2C917-AF42-4AE2-BC22-83035AFCB792}"/>
+                <a16:creationId xmlns:a16="http://schemas.microsoft.com/office/drawing/2014/main" id="{A0349722-9F2D-40B1-B796-E5D8E9384DF7}"/>
               </a:ext>
             </a:extLst>
           </p:cNvPr>
@@ -8391,7 +8386,7 @@
           <p:cNvPr id="12" name="readiness-panel-2">
             <a:extLst xmlns:a="http://schemas.openxmlformats.org/drawingml/2006/main">
               <a:ext uri="{FF2B5EF4-FFF2-40B4-BE49-F238E27FC236}">
-                <a16:creationId xmlns:a16="http://schemas.microsoft.com/office/drawing/2014/main" id="{2D827076-4C1B-48F9-BDCC-9B206E33F011}"/>
+                <a16:creationId xmlns:a16="http://schemas.microsoft.com/office/drawing/2014/main" id="{6A55F8F3-7BDD-4253-BB4F-22C5D2A1C5EA}"/>
               </a:ext>
             </a:extLst>
           </p:cNvPr>
@@ -8424,7 +8419,7 @@
           <p:cNvPr id="13" name="readiness-stat-2">
             <a:extLst xmlns:a="http://schemas.openxmlformats.org/drawingml/2006/main">
               <a:ext uri="{FF2B5EF4-FFF2-40B4-BE49-F238E27FC236}">
-                <a16:creationId xmlns:a16="http://schemas.microsoft.com/office/drawing/2014/main" id="{2FE7F0D1-4E45-458B-ADC1-51E9EF89167F}"/>
+                <a16:creationId xmlns:a16="http://schemas.microsoft.com/office/drawing/2014/main" id="{52E480CD-B6DD-4B47-AEF2-54F707348325}"/>
               </a:ext>
             </a:extLst>
           </p:cNvPr>
@@ -8482,7 +8477,7 @@
           <p:cNvPr id="14" name="readiness-label-2">
             <a:extLst xmlns:a="http://schemas.openxmlformats.org/drawingml/2006/main">
               <a:ext uri="{FF2B5EF4-FFF2-40B4-BE49-F238E27FC236}">
-                <a16:creationId xmlns:a16="http://schemas.microsoft.com/office/drawing/2014/main" id="{3B7DEF59-671B-4105-B90F-4FEE534AC7D6}"/>
+                <a16:creationId xmlns:a16="http://schemas.microsoft.com/office/drawing/2014/main" id="{9CD42FD1-A928-4B8F-9553-6938E4B418E8}"/>
               </a:ext>
             </a:extLst>
           </p:cNvPr>
@@ -8540,7 +8535,7 @@
           <p:cNvPr id="15" name="readiness-note-2">
             <a:extLst xmlns:a="http://schemas.openxmlformats.org/drawingml/2006/main">
               <a:ext uri="{FF2B5EF4-FFF2-40B4-BE49-F238E27FC236}">
-                <a16:creationId xmlns:a16="http://schemas.microsoft.com/office/drawing/2014/main" id="{696332BE-0770-40DC-AFC2-5DFBEF32C6BC}"/>
+                <a16:creationId xmlns:a16="http://schemas.microsoft.com/office/drawing/2014/main" id="{329A3BA5-8DEB-4674-966B-27D2BC85B51A}"/>
               </a:ext>
             </a:extLst>
           </p:cNvPr>
@@ -8598,7 +8593,7 @@
           <p:cNvPr id="16" name="remaining-title">
             <a:extLst xmlns:a="http://schemas.openxmlformats.org/drawingml/2006/main">
               <a:ext uri="{FF2B5EF4-FFF2-40B4-BE49-F238E27FC236}">
-                <a16:creationId xmlns:a16="http://schemas.microsoft.com/office/drawing/2014/main" id="{C0F0D2B7-812E-428E-BF08-D70DAAEE6474}"/>
+                <a16:creationId xmlns:a16="http://schemas.microsoft.com/office/drawing/2014/main" id="{C06125E8-12AF-495E-A6D5-825FBCB977F9}"/>
               </a:ext>
             </a:extLst>
           </p:cNvPr>
@@ -8656,7 +8651,7 @@
           <p:cNvPr id="17" name="remaining-list">
             <a:extLst xmlns:a="http://schemas.openxmlformats.org/drawingml/2006/main">
               <a:ext uri="{FF2B5EF4-FFF2-40B4-BE49-F238E27FC236}">
-                <a16:creationId xmlns:a16="http://schemas.microsoft.com/office/drawing/2014/main" id="{B96F2D4B-8EDA-4F50-91C0-C366B0055C90}"/>
+                <a16:creationId xmlns:a16="http://schemas.microsoft.com/office/drawing/2014/main" id="{7FC358BA-CA25-4CE3-8ADB-A05E629683AE}"/>
               </a:ext>
             </a:extLst>
           </p:cNvPr>
@@ -8668,7 +8663,7 @@
         <p:spPr>
           <a:xfrm xmlns:a="http://schemas.openxmlformats.org/drawingml/2006/main">
             <a:off x="495300" y="4610100"/>
-            <a:ext cx="6953250" cy="1143000"/>
+            <a:ext cx="10287000" cy="1143000"/>
           </a:xfrm>
           <a:prstGeom xmlns:a="http://schemas.openxmlformats.org/drawingml/2006/main" prst="rect">
             <a:avLst/>
@@ -8751,155 +8746,6 @@
                 <a:cs typeface="Helvetica Neue"/>
               </a:rPr>
               <a:t>3. Normalize references and add access dates only where records exist</a:t>
-            </a:r>
-          </a:p>
-        </p:txBody>
-      </p:sp>
-      <p:sp>
-        <p:nvSpPr>
-          <p:cNvPr id="18" name="pages-note">
-            <a:extLst xmlns:a="http://schemas.openxmlformats.org/drawingml/2006/main">
-              <a:ext uri="{FF2B5EF4-FFF2-40B4-BE49-F238E27FC236}">
-                <a16:creationId xmlns:a16="http://schemas.microsoft.com/office/drawing/2014/main" id="{6BAC13B1-1229-44D5-A485-B17D2E8FD6DE}"/>
-              </a:ext>
-            </a:extLst>
-          </p:cNvPr>
-          <p:cNvSpPr>
-            <a:spLocks xmlns:a="http://schemas.openxmlformats.org/drawingml/2006/main" noGrp="1"/>
-          </p:cNvSpPr>
-          <p:nvPr/>
-        </p:nvSpPr>
-        <p:spPr>
-          <a:xfrm xmlns:a="http://schemas.openxmlformats.org/drawingml/2006/main">
-            <a:off x="8001000" y="4076700"/>
-            <a:ext cx="3314700" cy="1676400"/>
-          </a:xfrm>
-          <a:prstGeom xmlns:a="http://schemas.openxmlformats.org/drawingml/2006/main" prst="rect">
-            <a:avLst/>
-          </a:prstGeom>
-          <a:solidFill xmlns:a="http://schemas.openxmlformats.org/drawingml/2006/main">
-            <a:srgbClr val="EAF5FA"/>
-          </a:solidFill>
-          <a:ln xmlns:a="http://schemas.openxmlformats.org/drawingml/2006/main" w="9525">
-            <a:solidFill>
-              <a:srgbClr val="B7DDEA"/>
-            </a:solidFill>
-            <a:prstDash val="solid"/>
-          </a:ln>
-        </p:spPr>
-      </p:sp>
-      <p:sp>
-        <p:nvSpPr>
-          <p:cNvPr id="19" name="pages-note-title">
-            <a:extLst xmlns:a="http://schemas.openxmlformats.org/drawingml/2006/main">
-              <a:ext uri="{FF2B5EF4-FFF2-40B4-BE49-F238E27FC236}">
-                <a16:creationId xmlns:a16="http://schemas.microsoft.com/office/drawing/2014/main" id="{1F90C1EA-4722-48D9-8DD9-EC1470AAE8BC}"/>
-              </a:ext>
-            </a:extLst>
-          </p:cNvPr>
-          <p:cNvSpPr>
-            <a:spLocks xmlns:a="http://schemas.openxmlformats.org/drawingml/2006/main" noGrp="1"/>
-          </p:cNvSpPr>
-          <p:nvPr/>
-        </p:nvSpPr>
-        <p:spPr>
-          <a:xfrm xmlns:a="http://schemas.openxmlformats.org/drawingml/2006/main">
-            <a:off x="8267700" y="4362450"/>
-            <a:ext cx="2781300" cy="323850"/>
-          </a:xfrm>
-          <a:prstGeom xmlns:a="http://schemas.openxmlformats.org/drawingml/2006/main" prst="rect">
-            <a:avLst/>
-          </a:prstGeom>
-          <a:noFill xmlns:a="http://schemas.openxmlformats.org/drawingml/2006/main"/>
-          <a:ln xmlns:a="http://schemas.openxmlformats.org/drawingml/2006/main" w="0">
-            <a:noFill/>
-            <a:prstDash val="solid"/>
-          </a:ln>
-        </p:spPr>
-        <p:txBody>
-          <a:bodyPr xmlns:a="http://schemas.openxmlformats.org/drawingml/2006/main" wrap="square" anchor="t">
-            <a:normAutofit fontScale="92424"/>
-          </a:bodyPr>
-          <a:lstStyle xmlns:a="http://schemas.openxmlformats.org/drawingml/2006/main"/>
-          <a:p xmlns:a="http://schemas.openxmlformats.org/drawingml/2006/main">
-            <a:pPr algn="l">
-              <a:defRPr sz="1650" b="1">
-                <a:solidFill>
-                  <a:srgbClr val="111418"/>
-                </a:solidFill>
-                <a:latin typeface="Helvetica Neue"/>
-                <a:ea typeface="Helvetica Neue"/>
-                <a:cs typeface="Helvetica Neue"/>
-              </a:defRPr>
-            </a:pPr>
-            <a:r>
-              <a:rPr sz="1650" b="1">
-                <a:solidFill>
-                  <a:srgbClr val="111418"/>
-                </a:solidFill>
-                <a:latin typeface="Helvetica Neue"/>
-                <a:ea typeface="Helvetica Neue"/>
-                <a:cs typeface="Helvetica Neue"/>
-              </a:rPr>
-              <a:t>Why 19 pages is acceptable</a:t>
-            </a:r>
-          </a:p>
-        </p:txBody>
-      </p:sp>
-      <p:sp>
-        <p:nvSpPr>
-          <p:cNvPr id="20" name="pages-note-copy">
-            <a:extLst xmlns:a="http://schemas.openxmlformats.org/drawingml/2006/main">
-              <a:ext uri="{FF2B5EF4-FFF2-40B4-BE49-F238E27FC236}">
-                <a16:creationId xmlns:a16="http://schemas.microsoft.com/office/drawing/2014/main" id="{F3B076FD-08E0-4C35-B2F6-8AB17A087B68}"/>
-              </a:ext>
-            </a:extLst>
-          </p:cNvPr>
-          <p:cNvSpPr>
-            <a:spLocks xmlns:a="http://schemas.openxmlformats.org/drawingml/2006/main" noGrp="1"/>
-          </p:cNvSpPr>
-          <p:nvPr/>
-        </p:nvSpPr>
-        <p:spPr>
-          <a:xfrm xmlns:a="http://schemas.openxmlformats.org/drawingml/2006/main">
-            <a:off x="8267700" y="4857750"/>
-            <a:ext cx="2781300" cy="723900"/>
-          </a:xfrm>
-          <a:prstGeom xmlns:a="http://schemas.openxmlformats.org/drawingml/2006/main" prst="rect">
-            <a:avLst/>
-          </a:prstGeom>
-          <a:noFill xmlns:a="http://schemas.openxmlformats.org/drawingml/2006/main"/>
-          <a:ln xmlns:a="http://schemas.openxmlformats.org/drawingml/2006/main" w="0">
-            <a:noFill/>
-            <a:prstDash val="solid"/>
-          </a:ln>
-        </p:spPr>
-        <p:txBody>
-          <a:bodyPr xmlns:a="http://schemas.openxmlformats.org/drawingml/2006/main" wrap="square" anchor="t">
-            <a:normAutofit fontScale="81373"/>
-          </a:bodyPr>
-          <a:lstStyle xmlns:a="http://schemas.openxmlformats.org/drawingml/2006/main"/>
-          <a:p xmlns:a="http://schemas.openxmlformats.org/drawingml/2006/main">
-            <a:pPr algn="l">
-              <a:defRPr sz="1275" b="0">
-                <a:solidFill>
-                  <a:srgbClr val="5C6673"/>
-                </a:solidFill>
-                <a:latin typeface="Helvetica Neue"/>
-                <a:ea typeface="Helvetica Neue"/>
-                <a:cs typeface="Helvetica Neue"/>
-              </a:defRPr>
-            </a:pPr>
-            <a:r>
-              <a:rPr sz="1275" b="0">
-                <a:solidFill>
-                  <a:srgbClr val="5C6673"/>
-                </a:solidFill>
-                <a:latin typeface="Helvetica Neue"/>
-                <a:ea typeface="Helvetica Neue"/>
-                <a:cs typeface="Helvetica Neue"/>
-              </a:rPr>
-              <a:t>CHI requires the single-column review format and evaluates Papers primarily by word count. Tables, figures, and references expand the page count.</a:t>
             </a:r>
           </a:p>
         </p:txBody>
@@ -8907,7 +8753,7 @@
     </p:spTree>
     <p:extLst>
       <p:ext uri="{BB962C8B-B14F-4D97-AF65-F5344CB8AC3E}">
-        <p14:creationId xmlns:p14="http://schemas.microsoft.com/office/powerpoint/2010/main" val="1245965085"/>
+        <p14:creationId xmlns:p14="http://schemas.microsoft.com/office/powerpoint/2010/main" val="1427234852"/>
       </p:ext>
     </p:extLst>
   </p:cSld>
@@ -8938,7 +8784,7 @@
           <p:cNvPr id="14" name="decision-eyebrow">
             <a:extLst xmlns:a="http://schemas.openxmlformats.org/drawingml/2006/main">
               <a:ext uri="{FF2B5EF4-FFF2-40B4-BE49-F238E27FC236}">
-                <a16:creationId xmlns:a16="http://schemas.microsoft.com/office/drawing/2014/main" id="{B5FEDE5C-BF62-4C9C-AF8F-8D4CA710FB8C}"/>
+                <a16:creationId xmlns:a16="http://schemas.microsoft.com/office/drawing/2014/main" id="{F533180D-DDF7-4EC1-A004-4283055D4F6F}"/>
               </a:ext>
             </a:extLst>
           </p:cNvPr>
@@ -8996,7 +8842,7 @@
           <p:cNvPr id="2" name="decision-title">
             <a:extLst xmlns:a="http://schemas.openxmlformats.org/drawingml/2006/main">
               <a:ext uri="{FF2B5EF4-FFF2-40B4-BE49-F238E27FC236}">
-                <a16:creationId xmlns:a16="http://schemas.microsoft.com/office/drawing/2014/main" id="{D28CBA4A-4C91-43BB-A522-372D27F90A43}"/>
+                <a16:creationId xmlns:a16="http://schemas.microsoft.com/office/drawing/2014/main" id="{D0E21B1D-ED5A-4F43-B959-8B84512AC72F}"/>
               </a:ext>
             </a:extLst>
           </p:cNvPr>
@@ -9054,7 +8900,7 @@
           <p:cNvPr id="3" name="decision-num-0">
             <a:extLst xmlns:a="http://schemas.openxmlformats.org/drawingml/2006/main">
               <a:ext uri="{FF2B5EF4-FFF2-40B4-BE49-F238E27FC236}">
-                <a16:creationId xmlns:a16="http://schemas.microsoft.com/office/drawing/2014/main" id="{E85039EF-DACA-4B98-8952-F8BF9ACE2984}"/>
+                <a16:creationId xmlns:a16="http://schemas.microsoft.com/office/drawing/2014/main" id="{03CBA0CF-BBF1-4400-8F53-B140831099AB}"/>
               </a:ext>
             </a:extLst>
           </p:cNvPr>
@@ -9112,7 +8958,7 @@
           <p:cNvPr id="4" name="decision-heading-0">
             <a:extLst xmlns:a="http://schemas.openxmlformats.org/drawingml/2006/main">
               <a:ext uri="{FF2B5EF4-FFF2-40B4-BE49-F238E27FC236}">
-                <a16:creationId xmlns:a16="http://schemas.microsoft.com/office/drawing/2014/main" id="{F4E07079-CA1A-4766-8514-380DD0FE8364}"/>
+                <a16:creationId xmlns:a16="http://schemas.microsoft.com/office/drawing/2014/main" id="{57B4EF54-F8B7-4492-ABC6-47D0E00F7854}"/>
               </a:ext>
             </a:extLst>
           </p:cNvPr>
@@ -9170,7 +9016,7 @@
           <p:cNvPr id="5" name="decision-body-0">
             <a:extLst xmlns:a="http://schemas.openxmlformats.org/drawingml/2006/main">
               <a:ext uri="{FF2B5EF4-FFF2-40B4-BE49-F238E27FC236}">
-                <a16:creationId xmlns:a16="http://schemas.microsoft.com/office/drawing/2014/main" id="{DB93C350-FB6B-428A-ADDA-3D86E6C22E9B}"/>
+                <a16:creationId xmlns:a16="http://schemas.microsoft.com/office/drawing/2014/main" id="{542A6B58-9ECA-4FF0-A90E-09C24EB4E2CF}"/>
               </a:ext>
             </a:extLst>
           </p:cNvPr>
@@ -9228,7 +9074,7 @@
           <p:cNvPr id="6" name="decision-num-1">
             <a:extLst xmlns:a="http://schemas.openxmlformats.org/drawingml/2006/main">
               <a:ext uri="{FF2B5EF4-FFF2-40B4-BE49-F238E27FC236}">
-                <a16:creationId xmlns:a16="http://schemas.microsoft.com/office/drawing/2014/main" id="{08327072-B5AA-4714-9B59-690BCECB0FD5}"/>
+                <a16:creationId xmlns:a16="http://schemas.microsoft.com/office/drawing/2014/main" id="{AEB6F88D-DC21-4138-B599-4926377CDAB3}"/>
               </a:ext>
             </a:extLst>
           </p:cNvPr>
@@ -9286,7 +9132,7 @@
           <p:cNvPr id="7" name="decision-heading-1">
             <a:extLst xmlns:a="http://schemas.openxmlformats.org/drawingml/2006/main">
               <a:ext uri="{FF2B5EF4-FFF2-40B4-BE49-F238E27FC236}">
-                <a16:creationId xmlns:a16="http://schemas.microsoft.com/office/drawing/2014/main" id="{3AF73E52-2A37-4F1C-A9AF-8716976B7E07}"/>
+                <a16:creationId xmlns:a16="http://schemas.microsoft.com/office/drawing/2014/main" id="{76D29A10-BA2C-435D-A67A-17E005181357}"/>
               </a:ext>
             </a:extLst>
           </p:cNvPr>
@@ -9344,7 +9190,7 @@
           <p:cNvPr id="8" name="decision-body-1">
             <a:extLst xmlns:a="http://schemas.openxmlformats.org/drawingml/2006/main">
               <a:ext uri="{FF2B5EF4-FFF2-40B4-BE49-F238E27FC236}">
-                <a16:creationId xmlns:a16="http://schemas.microsoft.com/office/drawing/2014/main" id="{CCA62087-18D8-4CCD-8F19-01C6C970CFE2}"/>
+                <a16:creationId xmlns:a16="http://schemas.microsoft.com/office/drawing/2014/main" id="{958A52CE-92C6-48A5-A028-C94E1B4D6D8D}"/>
               </a:ext>
             </a:extLst>
           </p:cNvPr>
@@ -9402,7 +9248,7 @@
           <p:cNvPr id="9" name="decision-num-2">
             <a:extLst xmlns:a="http://schemas.openxmlformats.org/drawingml/2006/main">
               <a:ext uri="{FF2B5EF4-FFF2-40B4-BE49-F238E27FC236}">
-                <a16:creationId xmlns:a16="http://schemas.microsoft.com/office/drawing/2014/main" id="{988D7868-7496-4607-9E55-26A820538953}"/>
+                <a16:creationId xmlns:a16="http://schemas.microsoft.com/office/drawing/2014/main" id="{7379684B-2AD5-4652-AD9F-ADE2A987BC28}"/>
               </a:ext>
             </a:extLst>
           </p:cNvPr>
@@ -9460,7 +9306,7 @@
           <p:cNvPr id="10" name="decision-heading-2">
             <a:extLst xmlns:a="http://schemas.openxmlformats.org/drawingml/2006/main">
               <a:ext uri="{FF2B5EF4-FFF2-40B4-BE49-F238E27FC236}">
-                <a16:creationId xmlns:a16="http://schemas.microsoft.com/office/drawing/2014/main" id="{53BD448F-0ECF-499E-B9B8-0D729483666A}"/>
+                <a16:creationId xmlns:a16="http://schemas.microsoft.com/office/drawing/2014/main" id="{675165EF-9BE5-4F91-86B6-B5AD08AF062C}"/>
               </a:ext>
             </a:extLst>
           </p:cNvPr>
@@ -9518,7 +9364,7 @@
           <p:cNvPr id="11" name="decision-body-2">
             <a:extLst xmlns:a="http://schemas.openxmlformats.org/drawingml/2006/main">
               <a:ext uri="{FF2B5EF4-FFF2-40B4-BE49-F238E27FC236}">
-                <a16:creationId xmlns:a16="http://schemas.microsoft.com/office/drawing/2014/main" id="{6CB120EB-AB84-40BC-ACEA-6ED75B874A7C}"/>
+                <a16:creationId xmlns:a16="http://schemas.microsoft.com/office/drawing/2014/main" id="{9EF513AC-E5CD-4F14-A8CD-413237AD2514}"/>
               </a:ext>
             </a:extLst>
           </p:cNvPr>
@@ -9576,7 +9422,7 @@
           <p:cNvPr id="12" name="stance-band">
             <a:extLst xmlns:a="http://schemas.openxmlformats.org/drawingml/2006/main">
               <a:ext uri="{FF2B5EF4-FFF2-40B4-BE49-F238E27FC236}">
-                <a16:creationId xmlns:a16="http://schemas.microsoft.com/office/drawing/2014/main" id="{1090236F-202C-487D-BE30-CC3DCB23A2C8}"/>
+                <a16:creationId xmlns:a16="http://schemas.microsoft.com/office/drawing/2014/main" id="{14C20C3B-CD2C-4843-8778-6897CBC6D980}"/>
               </a:ext>
             </a:extLst>
           </p:cNvPr>
@@ -9609,7 +9455,7 @@
           <p:cNvPr id="13" name="stance-copy">
             <a:extLst xmlns:a="http://schemas.openxmlformats.org/drawingml/2006/main">
               <a:ext uri="{FF2B5EF4-FFF2-40B4-BE49-F238E27FC236}">
-                <a16:creationId xmlns:a16="http://schemas.microsoft.com/office/drawing/2014/main" id="{629B7440-DC6D-4639-8E1A-C5140A076C7E}"/>
+                <a16:creationId xmlns:a16="http://schemas.microsoft.com/office/drawing/2014/main" id="{0D007540-1119-49E2-A7FD-A8FF69A11107}"/>
               </a:ext>
             </a:extLst>
           </p:cNvPr>
@@ -9665,7 +9511,7 @@
     </p:spTree>
     <p:extLst>
       <p:ext uri="{BB962C8B-B14F-4D97-AF65-F5344CB8AC3E}">
-        <p14:creationId xmlns:p14="http://schemas.microsoft.com/office/powerpoint/2010/main" val="865435549"/>
+        <p14:creationId xmlns:p14="http://schemas.microsoft.com/office/powerpoint/2010/main" val="426303075"/>
       </p:ext>
     </p:extLst>
   </p:cSld>

</xml_diff>

<commit_message>
Strengthen context-aware theory and domain-fit framing
</commit_message>
<xml_diff>
--- a/presentations/PERSONA_Professor_Revision_Update.pptx
+++ b/presentations/PERSONA_Professor_Revision_Update.pptx
@@ -2,21 +2,21 @@
 <file path=ppt/presentation.xml><?xml version="1.0" encoding="utf-8"?>
 <p:presentation xmlns:p="http://schemas.openxmlformats.org/presentationml/2006/main">
   <p:sldMasterIdLst>
-    <p:sldMasterId xmlns:r="http://schemas.openxmlformats.org/officeDocument/2006/relationships" id="2147483648" r:id="Rb58668e880f74853"/>
+    <p:sldMasterId xmlns:r="http://schemas.openxmlformats.org/officeDocument/2006/relationships" id="2147483648" r:id="Rc6178578c8a344c2"/>
   </p:sldMasterIdLst>
   <p:notesMasterIdLst>
-    <p:notesMasterId xmlns:r="http://schemas.openxmlformats.org/officeDocument/2006/relationships" r:id="Rcb909959d1c44029"/>
+    <p:notesMasterId xmlns:r="http://schemas.openxmlformats.org/officeDocument/2006/relationships" r:id="R87fb5df6a8364cd3"/>
   </p:notesMasterIdLst>
   <p:sldIdLst>
-    <p:sldId xmlns:r="http://schemas.openxmlformats.org/officeDocument/2006/relationships" id="256" r:id="R6747bdfdd57146f8"/>
-    <p:sldId xmlns:r="http://schemas.openxmlformats.org/officeDocument/2006/relationships" id="257" r:id="Rd7272bcf57f049e3"/>
-    <p:sldId xmlns:r="http://schemas.openxmlformats.org/officeDocument/2006/relationships" id="258" r:id="R5492538a1d224056"/>
-    <p:sldId xmlns:r="http://schemas.openxmlformats.org/officeDocument/2006/relationships" id="259" r:id="R654432e699254de3"/>
-    <p:sldId xmlns:r="http://schemas.openxmlformats.org/officeDocument/2006/relationships" id="260" r:id="R19bae1f7bc414577"/>
-    <p:sldId xmlns:r="http://schemas.openxmlformats.org/officeDocument/2006/relationships" id="261" r:id="R85707f26ac8a489e"/>
-    <p:sldId xmlns:r="http://schemas.openxmlformats.org/officeDocument/2006/relationships" id="262" r:id="Rac48723caeef4fad"/>
-    <p:sldId xmlns:r="http://schemas.openxmlformats.org/officeDocument/2006/relationships" id="263" r:id="Rb54a6bf42bf047a9"/>
-    <p:sldId xmlns:r="http://schemas.openxmlformats.org/officeDocument/2006/relationships" id="264" r:id="R9cdbd43c73844208"/>
+    <p:sldId xmlns:r="http://schemas.openxmlformats.org/officeDocument/2006/relationships" id="256" r:id="R1a18cc1259044972"/>
+    <p:sldId xmlns:r="http://schemas.openxmlformats.org/officeDocument/2006/relationships" id="257" r:id="Rbdb584fbca4f41a0"/>
+    <p:sldId xmlns:r="http://schemas.openxmlformats.org/officeDocument/2006/relationships" id="258" r:id="R77d9bd3761124b56"/>
+    <p:sldId xmlns:r="http://schemas.openxmlformats.org/officeDocument/2006/relationships" id="259" r:id="Rf94ece0efd924a08"/>
+    <p:sldId xmlns:r="http://schemas.openxmlformats.org/officeDocument/2006/relationships" id="260" r:id="R500fdfcf3c4e488e"/>
+    <p:sldId xmlns:r="http://schemas.openxmlformats.org/officeDocument/2006/relationships" id="261" r:id="Raa8c52c21b7f4f55"/>
+    <p:sldId xmlns:r="http://schemas.openxmlformats.org/officeDocument/2006/relationships" id="262" r:id="R551a85a1d67d4976"/>
+    <p:sldId xmlns:r="http://schemas.openxmlformats.org/officeDocument/2006/relationships" id="263" r:id="R7dfa73f83aea4564"/>
+    <p:sldId xmlns:r="http://schemas.openxmlformats.org/officeDocument/2006/relationships" id="264" r:id="R2c5dae4209464d1a"/>
   </p:sldIdLst>
   <p:sldSz cx="12192000" cy="6858000"/>
   <p:notesSz cx="6858000" cy="9144000"/>
@@ -645,7 +645,12 @@
           </a:p>
           <a:p xmlns:a="http://schemas.openxmlformats.org/drawingml/2006/main">
             <a:r>
-              <a:t>The revised framing answers the tautology criticism by changing what the comparison is claimed to establish.</a:t>
+              <a:t>The Episteme-Phronesis distinction is a conceptual lens, not a direct measurement mapping. HumT measures linguistic human-likeness rather than factual knowledge.</a:t>
+            </a:r>
+          </a:p>
+          <a:p xmlns:a="http://schemas.openxmlformats.org/drawingml/2006/main">
+            <a:r>
+              <a:t>The revised framing answers the tautology criticism by limiting what the comparison establishes.</a:t>
             </a:r>
           </a:p>
           <a:p xmlns:a="http://schemas.openxmlformats.org/drawingml/2006/main">
@@ -665,7 +670,12 @@
           </a:p>
           <a:p xmlns:a="http://schemas.openxmlformats.org/drawingml/2006/main">
             <a:r>
-              <a:t>- docs/CONCISE_REBUTTAL.md, Section 2</a:t>
+              <a:t>- docs/theory/PERSONA_THEORY.md</a:t>
+            </a:r>
+          </a:p>
+          <a:p xmlns:a="http://schemas.openxmlformats.org/drawingml/2006/main">
+            <a:r>
+              <a:t>- docs/CONCISE_REBUTTAL.md, Sections 2 and 10</a:t>
             </a:r>
           </a:p>
         </p:txBody>
@@ -740,7 +750,12 @@
           </a:p>
           <a:p xmlns:a="http://schemas.openxmlformats.org/drawingml/2006/main">
             <a:r>
-              <a:t>Explain that association is expected because fit contributes to appropriateness; the paper now avoids claiming full independence.</a:t>
+              <a:t>Domain Fit preserves the criteria originally shown to annotators as Contextual Fit. The name changed, but the definition, anchors, ratings, and data did not.</a:t>
+            </a:r>
+          </a:p>
+          <a:p xmlns:a="http://schemas.openxmlformats.org/drawingml/2006/main">
+            <a:r>
+              <a:t>Explain that association is expected because fit contributes to appropriateness. Separate rater pools reduce criterion contamination but do not prove construct independence.</a:t>
             </a:r>
           </a:p>
           <a:p xmlns:a="http://schemas.openxmlformats.org/drawingml/2006/main">
@@ -765,7 +780,12 @@
           </a:p>
           <a:p xmlns:a="http://schemas.openxmlformats.org/drawingml/2006/main">
             <a:r>
-              <a:t>- paper/revised5_shortened.tex, Construct Relationship Audit</a:t>
+              <a:t>- data/clean_domains/*/rubric.md</a:t>
+            </a:r>
+          </a:p>
+          <a:p xmlns:a="http://schemas.openxmlformats.org/drawingml/2006/main">
+            <a:r>
+              <a:t>- paper/revised5_shortened.tex, Domain Fit and Overall Appropriateness</a:t>
             </a:r>
           </a:p>
         </p:txBody>
@@ -1328,7 +1348,7 @@
   </p:cSld>
   <p:clrMap bg1="lt1" tx1="dk1" bg2="lt2" tx2="dk2" accent1="accent1" accent2="accent2" accent3="accent3" accent4="accent4" accent5="accent5" accent6="accent6" hlink="hlink" folHlink="folHlink"/>
   <p:sldLayoutIdLst>
-    <p:sldLayoutId xmlns:r="http://schemas.openxmlformats.org/officeDocument/2006/relationships" id="2147483649" r:id="Rda0407e4e06c4558"/>
+    <p:sldLayoutId xmlns:r="http://schemas.openxmlformats.org/officeDocument/2006/relationships" id="2147483649" r:id="R8ec3852c675c43b6"/>
   </p:sldLayoutIdLst>
   <p:txStyles>
     <p:titleStyle>
@@ -1856,7 +1876,7 @@
 </file>
 
 <file path=ppt/slides/charts/chart1.xml><?xml version="1.0" encoding="utf-8"?>
-<c:chartSpace xmlns:c="http://schemas.openxmlformats.org/drawingml/2006/chart">
+<c:chartSpace xmlns:c="http://schemas.openxmlformats.org/drawingml/2006/chart" xmlns:r="http://schemas.openxmlformats.org/officeDocument/2006/relationships">
   <c:lang val="en-US"/>
   <c:chart>
     <c:plotArea>
@@ -1877,39 +1897,45 @@
           </c:spPr>
           <c:invertIfNegative val="0"/>
           <c:cat>
-            <c:strLit>
-              <c:ptCount val="4"/>
-              <c:pt idx="0">
-                <c:v>Mental health</c:v>
-              </c:pt>
-              <c:pt idx="1">
-                <c:v>Education</c:v>
-              </c:pt>
-              <c:pt idx="2">
-                <c:v>Health</c:v>
-              </c:pt>
-              <c:pt idx="3">
-                <c:v>Pooled</c:v>
-              </c:pt>
-            </c:strLit>
+            <c:strRef>
+              <c:f>'Chart Data'!$A$2:$A$5</c:f>
+              <c:strCache>
+                <c:ptCount val="4"/>
+                <c:pt idx="0">
+                  <c:v>Mental health</c:v>
+                </c:pt>
+                <c:pt idx="1">
+                  <c:v>Education</c:v>
+                </c:pt>
+                <c:pt idx="2">
+                  <c:v>Health</c:v>
+                </c:pt>
+                <c:pt idx="3">
+                  <c:v>Pooled</c:v>
+                </c:pt>
+              </c:strCache>
+            </c:strRef>
           </c:cat>
           <c:val>
-            <c:numLit>
-              <c:formatCode>0.000</c:formatCode>
-              <c:ptCount val="4"/>
-              <c:pt idx="0">
-                <c:v>0.026</c:v>
-              </c:pt>
-              <c:pt idx="1">
-                <c:v>0.099</c:v>
-              </c:pt>
-              <c:pt idx="2">
-                <c:v>-0.007</c:v>
-              </c:pt>
-              <c:pt idx="3">
-                <c:v>0.221</c:v>
-              </c:pt>
-            </c:numLit>
+            <c:numRef>
+              <c:f>'Chart Data'!$B$2:$B$5</c:f>
+              <c:numCache>
+                <c:formatCode>0.000</c:formatCode>
+                <c:ptCount val="4"/>
+                <c:pt idx="0">
+                  <c:v>0.026</c:v>
+                </c:pt>
+                <c:pt idx="1">
+                  <c:v>0.099</c:v>
+                </c:pt>
+                <c:pt idx="2">
+                  <c:v>-0.007</c:v>
+                </c:pt>
+                <c:pt idx="3">
+                  <c:v>0.221</c:v>
+                </c:pt>
+              </c:numCache>
+            </c:numRef>
           </c:val>
         </c:ser>
         <c:ser>
@@ -1924,39 +1950,45 @@
             </a:solidFill>
           </c:spPr>
           <c:cat>
-            <c:strLit>
-              <c:ptCount val="4"/>
-              <c:pt idx="0">
-                <c:v>Mental health</c:v>
-              </c:pt>
-              <c:pt idx="1">
-                <c:v>Education</c:v>
-              </c:pt>
-              <c:pt idx="2">
-                <c:v>Health</c:v>
-              </c:pt>
-              <c:pt idx="3">
-                <c:v>Pooled</c:v>
-              </c:pt>
-            </c:strLit>
+            <c:strRef>
+              <c:f>'Chart Data'!$C$2:$C$5</c:f>
+              <c:strCache>
+                <c:ptCount val="4"/>
+                <c:pt idx="0">
+                  <c:v>Mental health</c:v>
+                </c:pt>
+                <c:pt idx="1">
+                  <c:v>Education</c:v>
+                </c:pt>
+                <c:pt idx="2">
+                  <c:v>Health</c:v>
+                </c:pt>
+                <c:pt idx="3">
+                  <c:v>Pooled</c:v>
+                </c:pt>
+              </c:strCache>
+            </c:strRef>
           </c:cat>
           <c:val>
-            <c:numLit>
-              <c:formatCode>0.000</c:formatCode>
-              <c:ptCount val="4"/>
-              <c:pt idx="0">
-                <c:v>0.659</c:v>
-              </c:pt>
-              <c:pt idx="1">
-                <c:v>0.562</c:v>
-              </c:pt>
-              <c:pt idx="2">
-                <c:v>0.256</c:v>
-              </c:pt>
-              <c:pt idx="3">
-                <c:v>0.499</c:v>
-              </c:pt>
-            </c:numLit>
+            <c:numRef>
+              <c:f>'Chart Data'!$D$2:$D$5</c:f>
+              <c:numCache>
+                <c:formatCode>0.000</c:formatCode>
+                <c:ptCount val="4"/>
+                <c:pt idx="0">
+                  <c:v>0.659</c:v>
+                </c:pt>
+                <c:pt idx="1">
+                  <c:v>0.562</c:v>
+                </c:pt>
+                <c:pt idx="2">
+                  <c:v>0.256</c:v>
+                </c:pt>
+                <c:pt idx="3">
+                  <c:v>0.499</c:v>
+                </c:pt>
+              </c:numCache>
+            </c:numRef>
           </c:val>
         </c:ser>
         <c:dLbls>
@@ -2102,6 +2134,9 @@
       <a:prstDash val="solid"/>
     </a:ln>
   </c:spPr>
+  <c:externalData r:id="rIdChartSnapshot1">
+    <c:autoUpdate val="0"/>
+  </c:externalData>
 </c:chartSpace>
 </file>
 
@@ -2159,6 +2194,7 @@
           <a:lstStyle xmlns:a="http://schemas.openxmlformats.org/drawingml/2006/main"/>
           <a:p xmlns:a="http://schemas.openxmlformats.org/drawingml/2006/main">
             <a:pPr algn="l">
+              <a:buNone/>
               <a:defRPr sz="1650" b="1">
                 <a:solidFill>
                   <a:srgbClr val="2376D8"/>
@@ -2217,6 +2253,7 @@
           <a:lstStyle xmlns:a="http://schemas.openxmlformats.org/drawingml/2006/main"/>
           <a:p xmlns:a="http://schemas.openxmlformats.org/drawingml/2006/main">
             <a:pPr algn="l">
+              <a:buNone/>
               <a:defRPr sz="4650" b="1">
                 <a:solidFill>
                   <a:srgbClr val="111418"/>
@@ -2308,6 +2345,7 @@
           <a:lstStyle xmlns:a="http://schemas.openxmlformats.org/drawingml/2006/main"/>
           <a:p xmlns:a="http://schemas.openxmlformats.org/drawingml/2006/main">
             <a:pPr algn="l">
+              <a:buNone/>
               <a:defRPr sz="1875" b="0">
                 <a:solidFill>
                   <a:srgbClr val="5C6673"/>
@@ -2331,6 +2369,7 @@
           </a:p>
           <a:p xmlns:a="http://schemas.openxmlformats.org/drawingml/2006/main">
             <a:pPr algn="l">
+              <a:buNone/>
               <a:defRPr sz="1875" b="0">
                 <a:solidFill>
                   <a:srgbClr val="5C6673"/>
@@ -2389,6 +2428,7 @@
           <a:lstStyle xmlns:a="http://schemas.openxmlformats.org/drawingml/2006/main"/>
           <a:p xmlns:a="http://schemas.openxmlformats.org/drawingml/2006/main">
             <a:pPr algn="r">
+              <a:buNone/>
               <a:defRPr sz="1350" b="0">
                 <a:solidFill>
                   <a:srgbClr val="5C6673"/>
@@ -2476,6 +2516,7 @@
           <a:lstStyle xmlns:a="http://schemas.openxmlformats.org/drawingml/2006/main"/>
           <a:p xmlns:a="http://schemas.openxmlformats.org/drawingml/2006/main">
             <a:pPr algn="l">
+              <a:buNone/>
               <a:defRPr sz="2925" b="1">
                 <a:solidFill>
                   <a:srgbClr val="111418"/>
@@ -2567,6 +2608,7 @@
           <a:lstStyle xmlns:a="http://schemas.openxmlformats.org/drawingml/2006/main"/>
           <a:p xmlns:a="http://schemas.openxmlformats.org/drawingml/2006/main">
             <a:pPr algn="r">
+              <a:buNone/>
               <a:defRPr sz="975" b="0">
                 <a:solidFill>
                   <a:srgbClr val="5C6673"/>
@@ -2625,6 +2667,7 @@
           <a:lstStyle xmlns:a="http://schemas.openxmlformats.org/drawingml/2006/main"/>
           <a:p xmlns:a="http://schemas.openxmlformats.org/drawingml/2006/main">
             <a:pPr algn="l">
+              <a:buNone/>
               <a:defRPr sz="4350" b="1">
                 <a:solidFill>
                   <a:srgbClr val="2376D8"/>
@@ -2683,6 +2726,7 @@
           <a:lstStyle xmlns:a="http://schemas.openxmlformats.org/drawingml/2006/main"/>
           <a:p xmlns:a="http://schemas.openxmlformats.org/drawingml/2006/main">
             <a:pPr algn="l">
+              <a:buNone/>
               <a:defRPr sz="1875" b="1">
                 <a:solidFill>
                   <a:srgbClr val="111418"/>
@@ -2741,6 +2785,7 @@
           <a:lstStyle xmlns:a="http://schemas.openxmlformats.org/drawingml/2006/main"/>
           <a:p xmlns:a="http://schemas.openxmlformats.org/drawingml/2006/main">
             <a:pPr algn="l">
+              <a:buNone/>
               <a:defRPr sz="1350" b="0">
                 <a:solidFill>
                   <a:srgbClr val="5C6673"/>
@@ -2759,7 +2804,7 @@
                 <a:ea typeface="Helvetica Neue"/>
                 <a:cs typeface="Helvetica Neue"/>
               </a:rPr>
-              <a:t>Narrowed the contribution without weakening the central argument.</a:t>
+              <a:t>Narrowed the claim and added a bounded Episteme-Phronesis lens.</a:t>
             </a:r>
           </a:p>
         </p:txBody>
@@ -2799,6 +2844,7 @@
           <a:lstStyle xmlns:a="http://schemas.openxmlformats.org/drawingml/2006/main"/>
           <a:p xmlns:a="http://schemas.openxmlformats.org/drawingml/2006/main">
             <a:pPr algn="l">
+              <a:buNone/>
               <a:defRPr sz="4350" b="1">
                 <a:solidFill>
                   <a:srgbClr val="2376D8"/>
@@ -2857,6 +2903,7 @@
           <a:lstStyle xmlns:a="http://schemas.openxmlformats.org/drawingml/2006/main"/>
           <a:p xmlns:a="http://schemas.openxmlformats.org/drawingml/2006/main">
             <a:pPr algn="l">
+              <a:buNone/>
               <a:defRPr sz="1875" b="1">
                 <a:solidFill>
                   <a:srgbClr val="111418"/>
@@ -2915,6 +2962,7 @@
           <a:lstStyle xmlns:a="http://schemas.openxmlformats.org/drawingml/2006/main"/>
           <a:p xmlns:a="http://schemas.openxmlformats.org/drawingml/2006/main">
             <a:pPr algn="l">
+              <a:buNone/>
               <a:defRPr sz="1350" b="0">
                 <a:solidFill>
                   <a:srgbClr val="5C6673"/>
@@ -2933,7 +2981,7 @@
                 <a:ea typeface="Helvetica Neue"/>
                 <a:cs typeface="Helvetica Neue"/>
               </a:rPr>
-              <a:t>Audited contextual fit versus overall appropriateness directly.</a:t>
+              <a:t>Defined Domain Fit and audited its relationship with overall appropriateness.</a:t>
             </a:r>
           </a:p>
         </p:txBody>
@@ -2973,6 +3021,7 @@
           <a:lstStyle xmlns:a="http://schemas.openxmlformats.org/drawingml/2006/main"/>
           <a:p xmlns:a="http://schemas.openxmlformats.org/drawingml/2006/main">
             <a:pPr algn="l">
+              <a:buNone/>
               <a:defRPr sz="4350" b="1">
                 <a:solidFill>
                   <a:srgbClr val="2376D8"/>
@@ -3031,6 +3080,7 @@
           <a:lstStyle xmlns:a="http://schemas.openxmlformats.org/drawingml/2006/main"/>
           <a:p xmlns:a="http://schemas.openxmlformats.org/drawingml/2006/main">
             <a:pPr algn="l">
+              <a:buNone/>
               <a:defRPr sz="1875" b="1">
                 <a:solidFill>
                   <a:srgbClr val="111418"/>
@@ -3089,6 +3139,7 @@
           <a:lstStyle xmlns:a="http://schemas.openxmlformats.org/drawingml/2006/main"/>
           <a:p xmlns:a="http://schemas.openxmlformats.org/drawingml/2006/main">
             <a:pPr algn="l">
+              <a:buNone/>
               <a:defRPr sz="1350" b="0">
                 <a:solidFill>
                   <a:srgbClr val="5C6673"/>
@@ -3147,6 +3198,7 @@
           <a:lstStyle xmlns:a="http://schemas.openxmlformats.org/drawingml/2006/main"/>
           <a:p xmlns:a="http://schemas.openxmlformats.org/drawingml/2006/main">
             <a:pPr algn="l">
+              <a:buNone/>
               <a:defRPr sz="4350" b="1">
                 <a:solidFill>
                   <a:srgbClr val="2376D8"/>
@@ -3205,6 +3257,7 @@
           <a:lstStyle xmlns:a="http://schemas.openxmlformats.org/drawingml/2006/main"/>
           <a:p xmlns:a="http://schemas.openxmlformats.org/drawingml/2006/main">
             <a:pPr algn="l">
+              <a:buNone/>
               <a:defRPr sz="1875" b="1">
                 <a:solidFill>
                   <a:srgbClr val="111418"/>
@@ -3263,6 +3316,7 @@
           <a:lstStyle xmlns:a="http://schemas.openxmlformats.org/drawingml/2006/main"/>
           <a:p xmlns:a="http://schemas.openxmlformats.org/drawingml/2006/main">
             <a:pPr algn="l">
+              <a:buNone/>
               <a:defRPr sz="1350" b="0">
                 <a:solidFill>
                   <a:srgbClr val="5C6673"/>
@@ -3354,6 +3408,7 @@
           <a:lstStyle xmlns:a="http://schemas.openxmlformats.org/drawingml/2006/main"/>
           <a:p xmlns:a="http://schemas.openxmlformats.org/drawingml/2006/main">
             <a:pPr algn="ctr">
+              <a:buNone/>
               <a:defRPr sz="1575" b="1">
                 <a:solidFill>
                   <a:srgbClr val="111418"/>
@@ -3441,6 +3496,7 @@
           <a:lstStyle xmlns:a="http://schemas.openxmlformats.org/drawingml/2006/main"/>
           <a:p xmlns:a="http://schemas.openxmlformats.org/drawingml/2006/main">
             <a:pPr algn="l">
+              <a:buNone/>
               <a:defRPr sz="2925" b="1">
                 <a:solidFill>
                   <a:srgbClr val="111418"/>
@@ -3532,6 +3588,7 @@
           <a:lstStyle xmlns:a="http://schemas.openxmlformats.org/drawingml/2006/main"/>
           <a:p xmlns:a="http://schemas.openxmlformats.org/drawingml/2006/main">
             <a:pPr algn="r">
+              <a:buNone/>
               <a:defRPr sz="975" b="0">
                 <a:solidFill>
                   <a:srgbClr val="5C6673"/>
@@ -3590,6 +3647,7 @@
           <a:lstStyle xmlns:a="http://schemas.openxmlformats.org/drawingml/2006/main"/>
           <a:p xmlns:a="http://schemas.openxmlformats.org/drawingml/2006/main">
             <a:pPr algn="l">
+              <a:buNone/>
               <a:defRPr sz="1350" b="1">
                 <a:solidFill>
                   <a:srgbClr val="A7443E"/>
@@ -3648,6 +3706,7 @@
           <a:lstStyle xmlns:a="http://schemas.openxmlformats.org/drawingml/2006/main"/>
           <a:p xmlns:a="http://schemas.openxmlformats.org/drawingml/2006/main">
             <a:pPr algn="l">
+              <a:buNone/>
               <a:defRPr sz="1350" b="1">
                 <a:solidFill>
                   <a:srgbClr val="167A5B"/>
@@ -3772,6 +3831,7 @@
           <a:lstStyle xmlns:a="http://schemas.openxmlformats.org/drawingml/2006/main"/>
           <a:p xmlns:a="http://schemas.openxmlformats.org/drawingml/2006/main">
             <a:pPr algn="l">
+              <a:buNone/>
               <a:defRPr sz="2175" b="1">
                 <a:solidFill>
                   <a:srgbClr val="111418"/>
@@ -3830,6 +3890,7 @@
           <a:lstStyle xmlns:a="http://schemas.openxmlformats.org/drawingml/2006/main"/>
           <a:p xmlns:a="http://schemas.openxmlformats.org/drawingml/2006/main">
             <a:pPr algn="l">
+              <a:buNone/>
               <a:defRPr sz="1425" b="0">
                 <a:solidFill>
                   <a:srgbClr val="5C6673"/>
@@ -3888,6 +3949,7 @@
           <a:lstStyle xmlns:a="http://schemas.openxmlformats.org/drawingml/2006/main"/>
           <a:p xmlns:a="http://schemas.openxmlformats.org/drawingml/2006/main">
             <a:pPr algn="l">
+              <a:buNone/>
               <a:defRPr sz="2175" b="1">
                 <a:solidFill>
                   <a:srgbClr val="111418"/>
@@ -3946,6 +4008,7 @@
           <a:lstStyle xmlns:a="http://schemas.openxmlformats.org/drawingml/2006/main"/>
           <a:p xmlns:a="http://schemas.openxmlformats.org/drawingml/2006/main">
             <a:pPr algn="l">
+              <a:buNone/>
               <a:defRPr sz="1425" b="0">
                 <a:solidFill>
                   <a:srgbClr val="5C6673"/>
@@ -4004,6 +4067,7 @@
           <a:lstStyle xmlns:a="http://schemas.openxmlformats.org/drawingml/2006/main"/>
           <a:p xmlns:a="http://schemas.openxmlformats.org/drawingml/2006/main">
             <a:pPr algn="ctr">
+              <a:buNone/>
               <a:defRPr sz="1650" b="1">
                 <a:solidFill>
                   <a:srgbClr val="2376D8"/>
@@ -4091,6 +4155,7 @@
           <a:lstStyle xmlns:a="http://schemas.openxmlformats.org/drawingml/2006/main"/>
           <a:p xmlns:a="http://schemas.openxmlformats.org/drawingml/2006/main">
             <a:pPr algn="l">
+              <a:buNone/>
               <a:defRPr sz="2925" b="1">
                 <a:solidFill>
                   <a:srgbClr val="111418"/>
@@ -4182,6 +4247,7 @@
           <a:lstStyle xmlns:a="http://schemas.openxmlformats.org/drawingml/2006/main"/>
           <a:p xmlns:a="http://schemas.openxmlformats.org/drawingml/2006/main">
             <a:pPr algn="r">
+              <a:buNone/>
               <a:defRPr sz="975" b="0">
                 <a:solidFill>
                   <a:srgbClr val="5C6673"/>
@@ -4240,6 +4306,7 @@
           <a:lstStyle xmlns:a="http://schemas.openxmlformats.org/drawingml/2006/main"/>
           <a:p xmlns:a="http://schemas.openxmlformats.org/drawingml/2006/main">
             <a:pPr algn="l">
+              <a:buNone/>
               <a:defRPr sz="1575" b="0">
                 <a:solidFill>
                   <a:srgbClr val="5C6673"/>
@@ -4258,14 +4325,14 @@
                 <a:ea typeface="Helvetica Neue"/>
                 <a:cs typeface="Helvetica Neue"/>
               </a:rPr>
-              <a:t>Contextual fit is narrower than holistic appropriateness. The audit reports both alignment and concrete disagreement.</a:t>
+              <a:t>Domain Fit is narrower than holistic appropriateness. The audit reports alignment and concrete disagreement.</a:t>
             </a:r>
           </a:p>
         </p:txBody>
       </p:sp>
       <p:graphicFrame>
         <p:nvGraphicFramePr>
-          <p:cNvPr id="14" name=""/>
+          <p:cNvPr id="16" name=""/>
           <p:cNvGraphicFramePr/>
           <p:nvPr/>
         </p:nvGraphicFramePr>
@@ -4699,6 +4766,7 @@
           <a:lstStyle xmlns:a="http://schemas.openxmlformats.org/drawingml/2006/main"/>
           <a:p xmlns:a="http://schemas.openxmlformats.org/drawingml/2006/main">
             <a:pPr algn="l">
+              <a:buNone/>
               <a:defRPr sz="1800" b="1">
                 <a:solidFill>
                   <a:srgbClr val="111418"/>
@@ -4757,6 +4825,7 @@
           <a:lstStyle xmlns:a="http://schemas.openxmlformats.org/drawingml/2006/main"/>
           <a:p xmlns:a="http://schemas.openxmlformats.org/drawingml/2006/main">
             <a:pPr algn="l">
+              <a:buNone/>
               <a:defRPr sz="1350" b="0">
                 <a:solidFill>
                   <a:srgbClr val="5C6673"/>
@@ -4785,6 +4854,7 @@
           </a:p>
           <a:p xmlns:a="http://schemas.openxmlformats.org/drawingml/2006/main">
             <a:pPr algn="l">
+              <a:buNone/>
               <a:defRPr sz="1350" b="0">
                 <a:solidFill>
                   <a:srgbClr val="5C6673"/>
@@ -4813,6 +4883,7 @@
           </a:p>
           <a:p xmlns:a="http://schemas.openxmlformats.org/drawingml/2006/main">
             <a:pPr algn="l">
+              <a:buNone/>
               <a:defRPr sz="1350" b="0">
                 <a:solidFill>
                   <a:srgbClr val="5C6673"/>
@@ -4841,6 +4912,7 @@
           </a:p>
           <a:p xmlns:a="http://schemas.openxmlformats.org/drawingml/2006/main">
             <a:pPr algn="l">
+              <a:buNone/>
               <a:defRPr sz="1350" b="0">
                 <a:solidFill>
                   <a:srgbClr val="5C6673"/>
@@ -4899,6 +4971,7 @@
           <a:lstStyle xmlns:a="http://schemas.openxmlformats.org/drawingml/2006/main"/>
           <a:p xmlns:a="http://schemas.openxmlformats.org/drawingml/2006/main">
             <a:pPr algn="ctr">
+              <a:buNone/>
               <a:defRPr sz="1425" b="1">
                 <a:solidFill>
                   <a:srgbClr val="2376D8"/>
@@ -4917,7 +4990,7 @@
                 <a:ea typeface="Helvetica Neue"/>
                 <a:cs typeface="Helvetica Neue"/>
               </a:rPr>
-              <a:t>Health also contains 33 cases with |F - OA| &gt;= 2, showing that holistic judgments can depart from contextual-fit ratings.</a:t>
+              <a:t>Health also contains 33 cases with |F - OA| &gt;= 2, showing that holistic judgments can depart from domain-fit ratings.</a:t>
             </a:r>
           </a:p>
         </p:txBody>
@@ -4986,6 +5059,7 @@
           <a:lstStyle xmlns:a="http://schemas.openxmlformats.org/drawingml/2006/main"/>
           <a:p xmlns:a="http://schemas.openxmlformats.org/drawingml/2006/main">
             <a:pPr algn="l">
+              <a:buNone/>
               <a:defRPr sz="2925" b="1">
                 <a:solidFill>
                   <a:srgbClr val="111418"/>
@@ -5077,6 +5151,7 @@
           <a:lstStyle xmlns:a="http://schemas.openxmlformats.org/drawingml/2006/main"/>
           <a:p xmlns:a="http://schemas.openxmlformats.org/drawingml/2006/main">
             <a:pPr algn="r">
+              <a:buNone/>
               <a:defRPr sz="975" b="0">
                 <a:solidFill>
                   <a:srgbClr val="5C6673"/>
@@ -5135,6 +5210,7 @@
           <a:lstStyle xmlns:a="http://schemas.openxmlformats.org/drawingml/2006/main"/>
           <a:p xmlns:a="http://schemas.openxmlformats.org/drawingml/2006/main">
             <a:pPr algn="l">
+              <a:buNone/>
               <a:defRPr sz="3300" b="1">
                 <a:solidFill>
                   <a:srgbClr val="2376D8"/>
@@ -5193,6 +5269,7 @@
           <a:lstStyle xmlns:a="http://schemas.openxmlformats.org/drawingml/2006/main"/>
           <a:p xmlns:a="http://schemas.openxmlformats.org/drawingml/2006/main">
             <a:pPr algn="l">
+              <a:buNone/>
               <a:defRPr sz="1350" b="0">
                 <a:solidFill>
                   <a:srgbClr val="5C6673"/>
@@ -5251,6 +5328,7 @@
           <a:lstStyle xmlns:a="http://schemas.openxmlformats.org/drawingml/2006/main"/>
           <a:p xmlns:a="http://schemas.openxmlformats.org/drawingml/2006/main">
             <a:pPr algn="l">
+              <a:buNone/>
               <a:defRPr sz="3300" b="1">
                 <a:solidFill>
                   <a:srgbClr val="2376D8"/>
@@ -5309,6 +5387,7 @@
           <a:lstStyle xmlns:a="http://schemas.openxmlformats.org/drawingml/2006/main"/>
           <a:p xmlns:a="http://schemas.openxmlformats.org/drawingml/2006/main">
             <a:pPr algn="l">
+              <a:buNone/>
               <a:defRPr sz="1350" b="0">
                 <a:solidFill>
                   <a:srgbClr val="5C6673"/>
@@ -5367,6 +5446,7 @@
           <a:lstStyle xmlns:a="http://schemas.openxmlformats.org/drawingml/2006/main"/>
           <a:p xmlns:a="http://schemas.openxmlformats.org/drawingml/2006/main">
             <a:pPr algn="l">
+              <a:buNone/>
               <a:defRPr sz="3300" b="1">
                 <a:solidFill>
                   <a:srgbClr val="2376D8"/>
@@ -5425,6 +5505,7 @@
           <a:lstStyle xmlns:a="http://schemas.openxmlformats.org/drawingml/2006/main"/>
           <a:p xmlns:a="http://schemas.openxmlformats.org/drawingml/2006/main">
             <a:pPr algn="l">
+              <a:buNone/>
               <a:defRPr sz="1350" b="0">
                 <a:solidFill>
                   <a:srgbClr val="5C6673"/>
@@ -5483,6 +5564,7 @@
           <a:lstStyle xmlns:a="http://schemas.openxmlformats.org/drawingml/2006/main"/>
           <a:p xmlns:a="http://schemas.openxmlformats.org/drawingml/2006/main">
             <a:pPr algn="l">
+              <a:buNone/>
               <a:defRPr sz="3300" b="1">
                 <a:solidFill>
                   <a:srgbClr val="2376D8"/>
@@ -5541,6 +5623,7 @@
           <a:lstStyle xmlns:a="http://schemas.openxmlformats.org/drawingml/2006/main"/>
           <a:p xmlns:a="http://schemas.openxmlformats.org/drawingml/2006/main">
             <a:pPr algn="l">
+              <a:buNone/>
               <a:defRPr sz="1350" b="0">
                 <a:solidFill>
                   <a:srgbClr val="5C6673"/>
@@ -5632,6 +5715,7 @@
           <a:lstStyle xmlns:a="http://schemas.openxmlformats.org/drawingml/2006/main"/>
           <a:p xmlns:a="http://schemas.openxmlformats.org/drawingml/2006/main">
             <a:pPr algn="l">
+              <a:buNone/>
               <a:defRPr sz="1500" b="1">
                 <a:solidFill>
                   <a:srgbClr val="111418"/>
@@ -5690,6 +5774,7 @@
           <a:lstStyle xmlns:a="http://schemas.openxmlformats.org/drawingml/2006/main"/>
           <a:p xmlns:a="http://schemas.openxmlformats.org/drawingml/2006/main">
             <a:pPr algn="l">
+              <a:buNone/>
               <a:defRPr sz="1350" b="0">
                 <a:solidFill>
                   <a:srgbClr val="5C6673"/>
@@ -5748,6 +5833,7 @@
           <a:lstStyle xmlns:a="http://schemas.openxmlformats.org/drawingml/2006/main"/>
           <a:p xmlns:a="http://schemas.openxmlformats.org/drawingml/2006/main">
             <a:pPr algn="l">
+              <a:buNone/>
               <a:defRPr sz="1500" b="1">
                 <a:solidFill>
                   <a:srgbClr val="111418"/>
@@ -5806,6 +5892,7 @@
           <a:lstStyle xmlns:a="http://schemas.openxmlformats.org/drawingml/2006/main"/>
           <a:p xmlns:a="http://schemas.openxmlformats.org/drawingml/2006/main">
             <a:pPr algn="l">
+              <a:buNone/>
               <a:defRPr sz="1350" b="0">
                 <a:solidFill>
                   <a:srgbClr val="5C6673"/>
@@ -5864,6 +5951,7 @@
           <a:lstStyle xmlns:a="http://schemas.openxmlformats.org/drawingml/2006/main"/>
           <a:p xmlns:a="http://schemas.openxmlformats.org/drawingml/2006/main">
             <a:pPr algn="l">
+              <a:buNone/>
               <a:defRPr sz="1500" b="1">
                 <a:solidFill>
                   <a:srgbClr val="111418"/>
@@ -5922,6 +6010,7 @@
           <a:lstStyle xmlns:a="http://schemas.openxmlformats.org/drawingml/2006/main"/>
           <a:p xmlns:a="http://schemas.openxmlformats.org/drawingml/2006/main">
             <a:pPr algn="l">
+              <a:buNone/>
               <a:defRPr sz="1350" b="0">
                 <a:solidFill>
                   <a:srgbClr val="5C6673"/>
@@ -5980,6 +6069,7 @@
           <a:lstStyle xmlns:a="http://schemas.openxmlformats.org/drawingml/2006/main"/>
           <a:p xmlns:a="http://schemas.openxmlformats.org/drawingml/2006/main">
             <a:pPr algn="l">
+              <a:buNone/>
               <a:defRPr sz="1500" b="1">
                 <a:solidFill>
                   <a:srgbClr val="111418"/>
@@ -6038,6 +6128,7 @@
           <a:lstStyle xmlns:a="http://schemas.openxmlformats.org/drawingml/2006/main"/>
           <a:p xmlns:a="http://schemas.openxmlformats.org/drawingml/2006/main">
             <a:pPr algn="l">
+              <a:buNone/>
               <a:defRPr sz="1350" b="0">
                 <a:solidFill>
                   <a:srgbClr val="5C6673"/>
@@ -6096,6 +6187,7 @@
           <a:lstStyle xmlns:a="http://schemas.openxmlformats.org/drawingml/2006/main"/>
           <a:p xmlns:a="http://schemas.openxmlformats.org/drawingml/2006/main">
             <a:pPr algn="l">
+              <a:buNone/>
               <a:defRPr sz="1500" b="1">
                 <a:solidFill>
                   <a:srgbClr val="111418"/>
@@ -6154,6 +6246,7 @@
           <a:lstStyle xmlns:a="http://schemas.openxmlformats.org/drawingml/2006/main"/>
           <a:p xmlns:a="http://schemas.openxmlformats.org/drawingml/2006/main">
             <a:pPr algn="l">
+              <a:buNone/>
               <a:defRPr sz="1350" b="0">
                 <a:solidFill>
                   <a:srgbClr val="5C6673"/>
@@ -6241,6 +6334,7 @@
           <a:lstStyle xmlns:a="http://schemas.openxmlformats.org/drawingml/2006/main"/>
           <a:p xmlns:a="http://schemas.openxmlformats.org/drawingml/2006/main">
             <a:pPr algn="l">
+              <a:buNone/>
               <a:defRPr sz="2925" b="1">
                 <a:solidFill>
                   <a:srgbClr val="111418"/>
@@ -6332,6 +6426,7 @@
           <a:lstStyle xmlns:a="http://schemas.openxmlformats.org/drawingml/2006/main"/>
           <a:p xmlns:a="http://schemas.openxmlformats.org/drawingml/2006/main">
             <a:pPr algn="r">
+              <a:buNone/>
               <a:defRPr sz="975" b="0">
                 <a:solidFill>
                   <a:srgbClr val="5C6673"/>
@@ -6357,7 +6452,7 @@
       </p:sp>
       <p:graphicFrame>
         <p:nvGraphicFramePr>
-          <p:cNvPr id="15" name="Chart"/>
+          <p:cNvPr id="17" name="Chart"/>
           <p:cNvGraphicFramePr/>
           <p:nvPr/>
         </p:nvGraphicFramePr>
@@ -6367,7 +6462,7 @@
         </p:xfrm>
         <a:graphic xmlns:a="http://schemas.openxmlformats.org/drawingml/2006/main">
           <a:graphicData uri="http://schemas.openxmlformats.org/drawingml/2006/chart">
-            <c:chart xmlns:r="http://schemas.openxmlformats.org/officeDocument/2006/relationships" xmlns:c="http://schemas.openxmlformats.org/drawingml/2006/chart" r:id="R96ddb2a546d24bfb"/>
+            <c:chart xmlns:r="http://schemas.openxmlformats.org/officeDocument/2006/relationships" xmlns:c="http://schemas.openxmlformats.org/drawingml/2006/chart" r:id="Rfc1706930e8b497d"/>
           </a:graphicData>
         </a:graphic>
       </p:graphicFrame>
@@ -6439,6 +6534,7 @@
           <a:lstStyle xmlns:a="http://schemas.openxmlformats.org/drawingml/2006/main"/>
           <a:p xmlns:a="http://schemas.openxmlformats.org/drawingml/2006/main">
             <a:pPr algn="l">
+              <a:buNone/>
               <a:defRPr sz="1800" b="1">
                 <a:solidFill>
                   <a:srgbClr val="111418"/>
@@ -6497,6 +6593,7 @@
           <a:lstStyle xmlns:a="http://schemas.openxmlformats.org/drawingml/2006/main"/>
           <a:p xmlns:a="http://schemas.openxmlformats.org/drawingml/2006/main">
             <a:pPr algn="l">
+              <a:buNone/>
               <a:defRPr sz="1350" b="1">
                 <a:solidFill>
                   <a:srgbClr val="5C6673"/>
@@ -6555,6 +6652,7 @@
           <a:lstStyle xmlns:a="http://schemas.openxmlformats.org/drawingml/2006/main"/>
           <a:p xmlns:a="http://schemas.openxmlformats.org/drawingml/2006/main">
             <a:pPr algn="l">
+              <a:buNone/>
               <a:defRPr sz="2100" b="1">
                 <a:solidFill>
                   <a:srgbClr val="111418"/>
@@ -6613,6 +6711,7 @@
           <a:lstStyle xmlns:a="http://schemas.openxmlformats.org/drawingml/2006/main"/>
           <a:p xmlns:a="http://schemas.openxmlformats.org/drawingml/2006/main">
             <a:pPr algn="l">
+              <a:buNone/>
               <a:defRPr sz="1425" b="0">
                 <a:solidFill>
                   <a:srgbClr val="5C6673"/>
@@ -6636,6 +6735,7 @@
           </a:p>
           <a:p xmlns:a="http://schemas.openxmlformats.org/drawingml/2006/main">
             <a:pPr algn="l">
+              <a:buNone/>
               <a:defRPr sz="1425" b="0">
                 <a:solidFill>
                   <a:srgbClr val="5C6673"/>
@@ -6727,6 +6827,7 @@
           <a:lstStyle xmlns:a="http://schemas.openxmlformats.org/drawingml/2006/main"/>
           <a:p xmlns:a="http://schemas.openxmlformats.org/drawingml/2006/main">
             <a:pPr algn="l">
+              <a:buNone/>
               <a:defRPr sz="1275" b="1">
                 <a:solidFill>
                   <a:srgbClr val="B56B12"/>
@@ -6814,6 +6915,7 @@
           <a:lstStyle xmlns:a="http://schemas.openxmlformats.org/drawingml/2006/main"/>
           <a:p xmlns:a="http://schemas.openxmlformats.org/drawingml/2006/main">
             <a:pPr algn="l">
+              <a:buNone/>
               <a:defRPr sz="2925" b="1">
                 <a:solidFill>
                   <a:srgbClr val="111418"/>
@@ -6905,6 +7007,7 @@
           <a:lstStyle xmlns:a="http://schemas.openxmlformats.org/drawingml/2006/main"/>
           <a:p xmlns:a="http://schemas.openxmlformats.org/drawingml/2006/main">
             <a:pPr algn="r">
+              <a:buNone/>
               <a:defRPr sz="975" b="0">
                 <a:solidFill>
                   <a:srgbClr val="5C6673"/>
@@ -6963,6 +7066,7 @@
           <a:lstStyle xmlns:a="http://schemas.openxmlformats.org/drawingml/2006/main"/>
           <a:p xmlns:a="http://schemas.openxmlformats.org/drawingml/2006/main">
             <a:pPr algn="l">
+              <a:buNone/>
               <a:defRPr sz="1425" b="1">
                 <a:solidFill>
                   <a:srgbClr val="2376D8"/>
@@ -7021,6 +7125,7 @@
           <a:lstStyle xmlns:a="http://schemas.openxmlformats.org/drawingml/2006/main"/>
           <a:p xmlns:a="http://schemas.openxmlformats.org/drawingml/2006/main">
             <a:pPr algn="l">
+              <a:buNone/>
               <a:defRPr sz="4800" b="1">
                 <a:solidFill>
                   <a:srgbClr val="111418"/>
@@ -7079,6 +7184,7 @@
           <a:lstStyle xmlns:a="http://schemas.openxmlformats.org/drawingml/2006/main"/>
           <a:p xmlns:a="http://schemas.openxmlformats.org/drawingml/2006/main">
             <a:pPr algn="l">
+              <a:buNone/>
               <a:defRPr sz="2100" b="0">
                 <a:solidFill>
                   <a:srgbClr val="5C6673"/>
@@ -7137,6 +7243,7 @@
           <a:lstStyle xmlns:a="http://schemas.openxmlformats.org/drawingml/2006/main"/>
           <a:p xmlns:a="http://schemas.openxmlformats.org/drawingml/2006/main">
             <a:pPr algn="l">
+              <a:buNone/>
               <a:defRPr sz="1800" b="1">
                 <a:solidFill>
                   <a:srgbClr val="111418"/>
@@ -7261,6 +7368,7 @@
           <a:lstStyle xmlns:a="http://schemas.openxmlformats.org/drawingml/2006/main"/>
           <a:p xmlns:a="http://schemas.openxmlformats.org/drawingml/2006/main">
             <a:pPr algn="l">
+              <a:buNone/>
               <a:defRPr sz="1500" b="1">
                 <a:solidFill>
                   <a:srgbClr val="111418"/>
@@ -7319,6 +7427,7 @@
           <a:lstStyle xmlns:a="http://schemas.openxmlformats.org/drawingml/2006/main"/>
           <a:p xmlns:a="http://schemas.openxmlformats.org/drawingml/2006/main">
             <a:pPr algn="l">
+              <a:buNone/>
               <a:defRPr sz="1200" b="0">
                 <a:solidFill>
                   <a:srgbClr val="5C6673"/>
@@ -7410,6 +7519,7 @@
           <a:lstStyle xmlns:a="http://schemas.openxmlformats.org/drawingml/2006/main"/>
           <a:p xmlns:a="http://schemas.openxmlformats.org/drawingml/2006/main">
             <a:pPr algn="l">
+              <a:buNone/>
               <a:defRPr sz="1500" b="1">
                 <a:solidFill>
                   <a:srgbClr val="111418"/>
@@ -7468,6 +7578,7 @@
           <a:lstStyle xmlns:a="http://schemas.openxmlformats.org/drawingml/2006/main"/>
           <a:p xmlns:a="http://schemas.openxmlformats.org/drawingml/2006/main">
             <a:pPr algn="l">
+              <a:buNone/>
               <a:defRPr sz="1200" b="0">
                 <a:solidFill>
                   <a:srgbClr val="5C6673"/>
@@ -7559,6 +7670,7 @@
           <a:lstStyle xmlns:a="http://schemas.openxmlformats.org/drawingml/2006/main"/>
           <a:p xmlns:a="http://schemas.openxmlformats.org/drawingml/2006/main">
             <a:pPr algn="l">
+              <a:buNone/>
               <a:defRPr sz="1500" b="1">
                 <a:solidFill>
                   <a:srgbClr val="111418"/>
@@ -7617,6 +7729,7 @@
           <a:lstStyle xmlns:a="http://schemas.openxmlformats.org/drawingml/2006/main"/>
           <a:p xmlns:a="http://schemas.openxmlformats.org/drawingml/2006/main">
             <a:pPr algn="l">
+              <a:buNone/>
               <a:defRPr sz="1200" b="0">
                 <a:solidFill>
                   <a:srgbClr val="5C6673"/>
@@ -7708,6 +7821,7 @@
           <a:lstStyle xmlns:a="http://schemas.openxmlformats.org/drawingml/2006/main"/>
           <a:p xmlns:a="http://schemas.openxmlformats.org/drawingml/2006/main">
             <a:pPr algn="l">
+              <a:buNone/>
               <a:defRPr sz="1500" b="1">
                 <a:solidFill>
                   <a:srgbClr val="111418"/>
@@ -7766,6 +7880,7 @@
           <a:lstStyle xmlns:a="http://schemas.openxmlformats.org/drawingml/2006/main"/>
           <a:p xmlns:a="http://schemas.openxmlformats.org/drawingml/2006/main">
             <a:pPr algn="l">
+              <a:buNone/>
               <a:defRPr sz="1200" b="0">
                 <a:solidFill>
                   <a:srgbClr val="5C6673"/>
@@ -7853,6 +7968,7 @@
           <a:lstStyle xmlns:a="http://schemas.openxmlformats.org/drawingml/2006/main"/>
           <a:p xmlns:a="http://schemas.openxmlformats.org/drawingml/2006/main">
             <a:pPr algn="l">
+              <a:buNone/>
               <a:defRPr sz="2925" b="1">
                 <a:solidFill>
                   <a:srgbClr val="111418"/>
@@ -7944,6 +8060,7 @@
           <a:lstStyle xmlns:a="http://schemas.openxmlformats.org/drawingml/2006/main"/>
           <a:p xmlns:a="http://schemas.openxmlformats.org/drawingml/2006/main">
             <a:pPr algn="r">
+              <a:buNone/>
               <a:defRPr sz="975" b="0">
                 <a:solidFill>
                   <a:srgbClr val="5C6673"/>
@@ -8035,6 +8152,7 @@
           <a:lstStyle xmlns:a="http://schemas.openxmlformats.org/drawingml/2006/main"/>
           <a:p xmlns:a="http://schemas.openxmlformats.org/drawingml/2006/main">
             <a:pPr algn="l">
+              <a:buNone/>
               <a:defRPr sz="3600" b="1">
                 <a:solidFill>
                   <a:srgbClr val="2376D8"/>
@@ -8053,7 +8171,7 @@
                 <a:ea typeface="Helvetica Neue"/>
                 <a:cs typeface="Helvetica Neue"/>
               </a:rPr>
-              <a:t>6,564</a:t>
+              <a:t>6,869</a:t>
             </a:r>
           </a:p>
         </p:txBody>
@@ -8093,6 +8211,7 @@
           <a:lstStyle xmlns:a="http://schemas.openxmlformats.org/drawingml/2006/main"/>
           <a:p xmlns:a="http://schemas.openxmlformats.org/drawingml/2006/main">
             <a:pPr algn="l">
+              <a:buNone/>
               <a:defRPr sz="1575" b="1">
                 <a:solidFill>
                   <a:srgbClr val="111418"/>
@@ -8151,6 +8270,7 @@
           <a:lstStyle xmlns:a="http://schemas.openxmlformats.org/drawingml/2006/main"/>
           <a:p xmlns:a="http://schemas.openxmlformats.org/drawingml/2006/main">
             <a:pPr algn="l">
+              <a:buNone/>
               <a:defRPr sz="1200" b="0">
                 <a:solidFill>
                   <a:srgbClr val="5C6673"/>
@@ -8242,6 +8362,7 @@
           <a:lstStyle xmlns:a="http://schemas.openxmlformats.org/drawingml/2006/main"/>
           <a:p xmlns:a="http://schemas.openxmlformats.org/drawingml/2006/main">
             <a:pPr algn="l">
+              <a:buNone/>
               <a:defRPr sz="3600" b="1">
                 <a:solidFill>
                   <a:srgbClr val="2376D8"/>
@@ -8300,6 +8421,7 @@
           <a:lstStyle xmlns:a="http://schemas.openxmlformats.org/drawingml/2006/main"/>
           <a:p xmlns:a="http://schemas.openxmlformats.org/drawingml/2006/main">
             <a:pPr algn="l">
+              <a:buNone/>
               <a:defRPr sz="1575" b="1">
                 <a:solidFill>
                   <a:srgbClr val="111418"/>
@@ -8358,6 +8480,7 @@
           <a:lstStyle xmlns:a="http://schemas.openxmlformats.org/drawingml/2006/main"/>
           <a:p xmlns:a="http://schemas.openxmlformats.org/drawingml/2006/main">
             <a:pPr algn="l">
+              <a:buNone/>
               <a:defRPr sz="1200" b="0">
                 <a:solidFill>
                   <a:srgbClr val="5C6673"/>
@@ -8449,6 +8572,7 @@
           <a:lstStyle xmlns:a="http://schemas.openxmlformats.org/drawingml/2006/main"/>
           <a:p xmlns:a="http://schemas.openxmlformats.org/drawingml/2006/main">
             <a:pPr algn="l">
+              <a:buNone/>
               <a:defRPr sz="3600" b="1">
                 <a:solidFill>
                   <a:srgbClr val="2376D8"/>
@@ -8467,7 +8591,7 @@
                 <a:ea typeface="Helvetica Neue"/>
                 <a:cs typeface="Helvetica Neue"/>
               </a:rPr>
-              <a:t>32</a:t>
+              <a:t>35</a:t>
             </a:r>
           </a:p>
         </p:txBody>
@@ -8507,6 +8631,7 @@
           <a:lstStyle xmlns:a="http://schemas.openxmlformats.org/drawingml/2006/main"/>
           <a:p xmlns:a="http://schemas.openxmlformats.org/drawingml/2006/main">
             <a:pPr algn="l">
+              <a:buNone/>
               <a:defRPr sz="1575" b="1">
                 <a:solidFill>
                   <a:srgbClr val="111418"/>
@@ -8565,6 +8690,7 @@
           <a:lstStyle xmlns:a="http://schemas.openxmlformats.org/drawingml/2006/main"/>
           <a:p xmlns:a="http://schemas.openxmlformats.org/drawingml/2006/main">
             <a:pPr algn="l">
+              <a:buNone/>
               <a:defRPr sz="1200" b="0">
                 <a:solidFill>
                   <a:srgbClr val="5C6673"/>
@@ -8623,6 +8749,7 @@
           <a:lstStyle xmlns:a="http://schemas.openxmlformats.org/drawingml/2006/main"/>
           <a:p xmlns:a="http://schemas.openxmlformats.org/drawingml/2006/main">
             <a:pPr algn="l">
+              <a:buNone/>
               <a:defRPr sz="1950" b="1">
                 <a:solidFill>
                   <a:srgbClr val="111418"/>
@@ -8681,6 +8808,7 @@
           <a:lstStyle xmlns:a="http://schemas.openxmlformats.org/drawingml/2006/main"/>
           <a:p xmlns:a="http://schemas.openxmlformats.org/drawingml/2006/main">
             <a:pPr algn="l">
+              <a:buNone/>
               <a:defRPr sz="1575" b="0">
                 <a:solidFill>
                   <a:srgbClr val="5C6673"/>
@@ -8704,6 +8832,7 @@
           </a:p>
           <a:p xmlns:a="http://schemas.openxmlformats.org/drawingml/2006/main">
             <a:pPr algn="l">
+              <a:buNone/>
               <a:defRPr sz="1575" b="0">
                 <a:solidFill>
                   <a:srgbClr val="5C6673"/>
@@ -8727,6 +8856,7 @@
           </a:p>
           <a:p xmlns:a="http://schemas.openxmlformats.org/drawingml/2006/main">
             <a:pPr algn="l">
+              <a:buNone/>
               <a:defRPr sz="1575" b="0">
                 <a:solidFill>
                   <a:srgbClr val="5C6673"/>
@@ -8814,6 +8944,7 @@
           <a:lstStyle xmlns:a="http://schemas.openxmlformats.org/drawingml/2006/main"/>
           <a:p xmlns:a="http://schemas.openxmlformats.org/drawingml/2006/main">
             <a:pPr algn="l">
+              <a:buNone/>
               <a:defRPr sz="1500" b="1">
                 <a:solidFill>
                   <a:srgbClr val="2376D8"/>
@@ -8872,6 +9003,7 @@
           <a:lstStyle xmlns:a="http://schemas.openxmlformats.org/drawingml/2006/main"/>
           <a:p xmlns:a="http://schemas.openxmlformats.org/drawingml/2006/main">
             <a:pPr algn="l">
+              <a:buNone/>
               <a:defRPr sz="3675" b="1">
                 <a:solidFill>
                   <a:srgbClr val="111418"/>
@@ -8930,6 +9062,7 @@
           <a:lstStyle xmlns:a="http://schemas.openxmlformats.org/drawingml/2006/main"/>
           <a:p xmlns:a="http://schemas.openxmlformats.org/drawingml/2006/main">
             <a:pPr algn="l">
+              <a:buNone/>
               <a:defRPr sz="2175" b="1">
                 <a:solidFill>
                   <a:srgbClr val="2376D8"/>
@@ -8988,6 +9121,7 @@
           <a:lstStyle xmlns:a="http://schemas.openxmlformats.org/drawingml/2006/main"/>
           <a:p xmlns:a="http://schemas.openxmlformats.org/drawingml/2006/main">
             <a:pPr algn="l">
+              <a:buNone/>
               <a:defRPr sz="1800" b="1">
                 <a:solidFill>
                   <a:srgbClr val="111418"/>
@@ -9046,6 +9180,7 @@
           <a:lstStyle xmlns:a="http://schemas.openxmlformats.org/drawingml/2006/main"/>
           <a:p xmlns:a="http://schemas.openxmlformats.org/drawingml/2006/main">
             <a:pPr algn="l">
+              <a:buNone/>
               <a:defRPr sz="1425" b="0">
                 <a:solidFill>
                   <a:srgbClr val="5C6673"/>
@@ -9104,6 +9239,7 @@
           <a:lstStyle xmlns:a="http://schemas.openxmlformats.org/drawingml/2006/main"/>
           <a:p xmlns:a="http://schemas.openxmlformats.org/drawingml/2006/main">
             <a:pPr algn="l">
+              <a:buNone/>
               <a:defRPr sz="2175" b="1">
                 <a:solidFill>
                   <a:srgbClr val="2376D8"/>
@@ -9162,6 +9298,7 @@
           <a:lstStyle xmlns:a="http://schemas.openxmlformats.org/drawingml/2006/main"/>
           <a:p xmlns:a="http://schemas.openxmlformats.org/drawingml/2006/main">
             <a:pPr algn="l">
+              <a:buNone/>
               <a:defRPr sz="1800" b="1">
                 <a:solidFill>
                   <a:srgbClr val="111418"/>
@@ -9220,6 +9357,7 @@
           <a:lstStyle xmlns:a="http://schemas.openxmlformats.org/drawingml/2006/main"/>
           <a:p xmlns:a="http://schemas.openxmlformats.org/drawingml/2006/main">
             <a:pPr algn="l">
+              <a:buNone/>
               <a:defRPr sz="1425" b="0">
                 <a:solidFill>
                   <a:srgbClr val="5C6673"/>
@@ -9278,6 +9416,7 @@
           <a:lstStyle xmlns:a="http://schemas.openxmlformats.org/drawingml/2006/main"/>
           <a:p xmlns:a="http://schemas.openxmlformats.org/drawingml/2006/main">
             <a:pPr algn="l">
+              <a:buNone/>
               <a:defRPr sz="2175" b="1">
                 <a:solidFill>
                   <a:srgbClr val="2376D8"/>
@@ -9336,6 +9475,7 @@
           <a:lstStyle xmlns:a="http://schemas.openxmlformats.org/drawingml/2006/main"/>
           <a:p xmlns:a="http://schemas.openxmlformats.org/drawingml/2006/main">
             <a:pPr algn="l">
+              <a:buNone/>
               <a:defRPr sz="1800" b="1">
                 <a:solidFill>
                   <a:srgbClr val="111418"/>
@@ -9394,6 +9534,7 @@
           <a:lstStyle xmlns:a="http://schemas.openxmlformats.org/drawingml/2006/main"/>
           <a:p xmlns:a="http://schemas.openxmlformats.org/drawingml/2006/main">
             <a:pPr algn="l">
+              <a:buNone/>
               <a:defRPr sz="1425" b="0">
                 <a:solidFill>
                   <a:srgbClr val="5C6673"/>
@@ -9485,6 +9626,7 @@
           <a:lstStyle xmlns:a="http://schemas.openxmlformats.org/drawingml/2006/main"/>
           <a:p xmlns:a="http://schemas.openxmlformats.org/drawingml/2006/main">
             <a:pPr algn="ctr">
+              <a:buNone/>
               <a:defRPr sz="1575" b="1">
                 <a:solidFill>
                   <a:srgbClr val="FFFFFF"/>

</xml_diff>

<commit_message>
Correct annotator provenance and disclose Group B constraint
</commit_message>
<xml_diff>
--- a/presentations/PERSONA_Professor_Revision_Update.pptx
+++ b/presentations/PERSONA_Professor_Revision_Update.pptx
@@ -2,21 +2,21 @@
 <file path=ppt/presentation.xml><?xml version="1.0" encoding="utf-8"?>
 <p:presentation xmlns:p="http://schemas.openxmlformats.org/presentationml/2006/main">
   <p:sldMasterIdLst>
-    <p:sldMasterId xmlns:r="http://schemas.openxmlformats.org/officeDocument/2006/relationships" id="2147483648" r:id="Rc6178578c8a344c2"/>
+    <p:sldMasterId xmlns:r="http://schemas.openxmlformats.org/officeDocument/2006/relationships" id="2147483648" r:id="Re9e82b80e68541a7"/>
   </p:sldMasterIdLst>
   <p:notesMasterIdLst>
-    <p:notesMasterId xmlns:r="http://schemas.openxmlformats.org/officeDocument/2006/relationships" r:id="R87fb5df6a8364cd3"/>
+    <p:notesMasterId xmlns:r="http://schemas.openxmlformats.org/officeDocument/2006/relationships" r:id="R7e80b818ca0b4758"/>
   </p:notesMasterIdLst>
   <p:sldIdLst>
-    <p:sldId xmlns:r="http://schemas.openxmlformats.org/officeDocument/2006/relationships" id="256" r:id="R1a18cc1259044972"/>
-    <p:sldId xmlns:r="http://schemas.openxmlformats.org/officeDocument/2006/relationships" id="257" r:id="Rbdb584fbca4f41a0"/>
-    <p:sldId xmlns:r="http://schemas.openxmlformats.org/officeDocument/2006/relationships" id="258" r:id="R77d9bd3761124b56"/>
-    <p:sldId xmlns:r="http://schemas.openxmlformats.org/officeDocument/2006/relationships" id="259" r:id="Rf94ece0efd924a08"/>
-    <p:sldId xmlns:r="http://schemas.openxmlformats.org/officeDocument/2006/relationships" id="260" r:id="R500fdfcf3c4e488e"/>
-    <p:sldId xmlns:r="http://schemas.openxmlformats.org/officeDocument/2006/relationships" id="261" r:id="Raa8c52c21b7f4f55"/>
-    <p:sldId xmlns:r="http://schemas.openxmlformats.org/officeDocument/2006/relationships" id="262" r:id="R551a85a1d67d4976"/>
-    <p:sldId xmlns:r="http://schemas.openxmlformats.org/officeDocument/2006/relationships" id="263" r:id="R7dfa73f83aea4564"/>
-    <p:sldId xmlns:r="http://schemas.openxmlformats.org/officeDocument/2006/relationships" id="264" r:id="R2c5dae4209464d1a"/>
+    <p:sldId xmlns:r="http://schemas.openxmlformats.org/officeDocument/2006/relationships" id="256" r:id="Rd1eefb6fe9ce4f65"/>
+    <p:sldId xmlns:r="http://schemas.openxmlformats.org/officeDocument/2006/relationships" id="257" r:id="Rd6533f2d41684dad"/>
+    <p:sldId xmlns:r="http://schemas.openxmlformats.org/officeDocument/2006/relationships" id="258" r:id="R9df7b31c356a4b71"/>
+    <p:sldId xmlns:r="http://schemas.openxmlformats.org/officeDocument/2006/relationships" id="259" r:id="R315638097509435e"/>
+    <p:sldId xmlns:r="http://schemas.openxmlformats.org/officeDocument/2006/relationships" id="260" r:id="Re89a103c5b824301"/>
+    <p:sldId xmlns:r="http://schemas.openxmlformats.org/officeDocument/2006/relationships" id="261" r:id="Rcc0f5f523c6840f7"/>
+    <p:sldId xmlns:r="http://schemas.openxmlformats.org/officeDocument/2006/relationships" id="262" r:id="R901f3a5026eb4d77"/>
+    <p:sldId xmlns:r="http://schemas.openxmlformats.org/officeDocument/2006/relationships" id="263" r:id="Re2a30fad6fc642ba"/>
+    <p:sldId xmlns:r="http://schemas.openxmlformats.org/officeDocument/2006/relationships" id="264" r:id="R57e9cad77fb6421f"/>
   </p:sldIdLst>
   <p:sldSz cx="12192000" cy="6858000"/>
   <p:notesSz cx="6858000" cy="9144000"/>
@@ -1348,7 +1348,7 @@
   </p:cSld>
   <p:clrMap bg1="lt1" tx1="dk1" bg2="lt2" tx2="dk2" accent1="accent1" accent2="accent2" accent3="accent3" accent4="accent4" accent5="accent5" accent6="accent6" hlink="hlink" folHlink="folHlink"/>
   <p:sldLayoutIdLst>
-    <p:sldLayoutId xmlns:r="http://schemas.openxmlformats.org/officeDocument/2006/relationships" id="2147483649" r:id="R8ec3852c675c43b6"/>
+    <p:sldLayoutId xmlns:r="http://schemas.openxmlformats.org/officeDocument/2006/relationships" id="2147483649" r:id="R3c28d20d2e374aff"/>
   </p:sldLayoutIdLst>
   <p:txStyles>
     <p:titleStyle>
@@ -6462,7 +6462,7 @@
         </p:xfrm>
         <a:graphic xmlns:a="http://schemas.openxmlformats.org/drawingml/2006/main">
           <a:graphicData uri="http://schemas.openxmlformats.org/drawingml/2006/chart">
-            <c:chart xmlns:r="http://schemas.openxmlformats.org/officeDocument/2006/relationships" xmlns:c="http://schemas.openxmlformats.org/drawingml/2006/chart" r:id="Rfc1706930e8b497d"/>
+            <c:chart xmlns:r="http://schemas.openxmlformats.org/officeDocument/2006/relationships" xmlns:c="http://schemas.openxmlformats.org/drawingml/2006/chart" r:id="Rc06d682d29044978"/>
           </a:graphicData>
         </a:graphic>
       </p:graphicFrame>
@@ -7724,7 +7724,7 @@
         </p:spPr>
         <p:txBody>
           <a:bodyPr xmlns:a="http://schemas.openxmlformats.org/drawingml/2006/main" wrap="square" anchor="t">
-            <a:normAutofit fontScale="88247"/>
+            <a:normAutofit fontScale="92209"/>
           </a:bodyPr>
           <a:lstStyle xmlns:a="http://schemas.openxmlformats.org/drawingml/2006/main"/>
           <a:p xmlns:a="http://schemas.openxmlformats.org/drawingml/2006/main">
@@ -7748,7 +7748,7 @@
                 <a:ea typeface="Helvetica Neue"/>
                 <a:cs typeface="Helvetica Neue"/>
               </a:rPr>
-              <a:t>Separate rater groups, independent judgments, and AI-use boundaries documented.</a:t>
+              <a:t>Separate rater groups and AI-use boundaries documented; Group B familiarity disclosed.</a:t>
             </a:r>
           </a:p>
         </p:txBody>
@@ -8171,7 +8171,7 @@
                 <a:ea typeface="Helvetica Neue"/>
                 <a:cs typeface="Helvetica Neue"/>
               </a:rPr>
-              <a:t>6,869</a:t>
+              <a:t>6,936</a:t>
             </a:r>
           </a:p>
         </p:txBody>

</xml_diff>